<commit_message>
statistic_selector and statistic_cutoff labels changed
statistic_selector and statistic_cutoff labels changed to padj_method and padj_cutoff respectively. Closes #11
</commit_message>
<xml_diff>
--- a/example1-metabolomics/results-A/report.pptx
+++ b/example1-metabolomics/results-A/report.pptx
@@ -5,22 +5,26 @@
     <p:sldMasterId id="2147483660" r:id="rId1"/>
   </p:sldMasterIdLst>
   <p:notesMasterIdLst>
-    <p:notesMasterId r:id="rId2"/>
+    <p:notesMasterId r:id="rId16"/>
   </p:notesMasterIdLst>
   <p:handoutMasterIdLst>
-    <p:handoutMasterId r:id="rId3"/>
+    <p:handoutMasterId r:id="rId17"/>
   </p:handoutMasterIdLst>
   <p:sldIdLst>
-    <p:sldId id="256" r:id="rId8"/>
-    <p:sldId id="257" r:id="rId9"/>
-    <p:sldId id="258" r:id="rId10"/>
-    <p:sldId id="259" r:id="rId11"/>
-    <p:sldId id="260" r:id="rId12"/>
-    <p:sldId id="261" r:id="rId13"/>
-    <p:sldId id="262" r:id="rId14"/>
-    <p:sldId id="263" r:id="rId15"/>
-    <p:sldId id="264" r:id="rId16"/>
-    <p:sldId id="265" r:id="rId17"/>
+    <p:sldId id="256" r:id="rId2"/>
+    <p:sldId id="257" r:id="rId3"/>
+    <p:sldId id="258" r:id="rId4"/>
+    <p:sldId id="259" r:id="rId5"/>
+    <p:sldId id="260" r:id="rId6"/>
+    <p:sldId id="261" r:id="rId7"/>
+    <p:sldId id="262" r:id="rId8"/>
+    <p:sldId id="263" r:id="rId9"/>
+    <p:sldId id="264" r:id="rId10"/>
+    <p:sldId id="265" r:id="rId11"/>
+    <p:sldId id="266" r:id="rId12"/>
+    <p:sldId id="267" r:id="rId13"/>
+    <p:sldId id="268" r:id="rId14"/>
+    <p:sldId id="269" r:id="rId15"/>
   </p:sldIdLst>
   <p:sldSz cx="9144000" cy="6858000" type="screen4x3"/>
   <p:notesSz cx="6858000" cy="9144000"/>
@@ -123,7 +127,22 @@
     <p:ext uri="{521415D9-36F7-43E2-AB2F-B90AF26B5E84}">
       <p14:sectionLst xmlns:p14="http://schemas.microsoft.com/office/powerpoint/2010/main">
         <p14:section name="Default Section" id="{23E95266-8A91-634B-9D8A-82E9C2DFC7E6}">
-          <p14:sldIdLst/>
+          <p14:sldIdLst>
+            <p14:sldId id="256"/>
+            <p14:sldId id="257"/>
+            <p14:sldId id="258"/>
+            <p14:sldId id="259"/>
+            <p14:sldId id="260"/>
+            <p14:sldId id="261"/>
+            <p14:sldId id="262"/>
+            <p14:sldId id="263"/>
+            <p14:sldId id="264"/>
+            <p14:sldId id="265"/>
+            <p14:sldId id="266"/>
+            <p14:sldId id="267"/>
+            <p14:sldId id="268"/>
+            <p14:sldId id="269"/>
+          </p14:sldIdLst>
         </p14:section>
       </p14:sectionLst>
     </p:ext>
@@ -227,7 +246,7 @@
           <a:p>
             <a:fld id="{12475388-B706-A848-A46B-DDB877936374}" type="datetimeFigureOut">
               <a:rPr lang="en-US" smtClean="0"/>
-              <a:t>1/29/18</a:t>
+              <a:t>3/29/23</a:t>
             </a:fld>
             <a:endParaRPr lang="en-US"/>
           </a:p>
@@ -393,7 +412,7 @@
           <a:p>
             <a:fld id="{A5587B2F-58BE-554B-B170-DCECE273C696}" type="datetimeFigureOut">
               <a:rPr lang="en-US" smtClean="0"/>
-              <a:t>1/29/18</a:t>
+              <a:t>3/29/23</a:t>
             </a:fld>
             <a:endParaRPr lang="en-US"/>
           </a:p>
@@ -1812,7 +1831,6 @@
           <a:lstStyle/>
           <a:p>
             <a:r>
-              <a:rPr/>
               <a:t>Project Report</a:t>
             </a:r>
           </a:p>
@@ -1839,7 +1857,6 @@
           <a:lstStyle/>
           <a:p>
             <a:r>
-              <a:rPr/>
               <a:t>Metabolomics Analysis</a:t>
             </a:r>
           </a:p>
@@ -1891,8 +1908,7 @@
           <a:lstStyle/>
           <a:p>
             <a:r>
-              <a:rPr/>
-              <a:t>Comparison MaleMRD_MaleMHFD_FemMRD_FemMHFD</a:t>
+              <a:t>Comparison RDDam_HFDDam_MaleMRD_MaleMHFD_FemMRD_FemMHFD</a:t>
             </a:r>
           </a:p>
         </p:txBody>
@@ -1918,8 +1934,7 @@
           <a:lstStyle/>
           <a:p>
             <a:r>
-              <a:rPr/>
-              <a:t>Differential FDR&lt;0.25</a:t>
+              <a:t>Normalized PCA</a:t>
             </a:r>
           </a:p>
         </p:txBody>
@@ -1945,15 +1960,14 @@
           <a:lstStyle/>
           <a:p>
             <a:r>
-              <a:rPr/>
-              <a:t>Complete Set FDR=1</a:t>
+              <a:t>Raw PCA</a:t>
             </a:r>
           </a:p>
         </p:txBody>
       </p:sp>
       <p:pic>
         <p:nvPicPr>
-          <p:cNvPr id="5" name="" descr=""/>
+          <p:cNvPr id="5" name="Content Placeholder 4"/>
           <p:cNvPicPr>
             <a:picLocks noGrp="1"/>
           </p:cNvPicPr>
@@ -1962,7 +1976,7 @@
           </p:nvPr>
         </p:nvPicPr>
         <p:blipFill>
-          <a:blip cstate="print" r:embed="rId2"/>
+          <a:blip r:embed="rId2" cstate="print"/>
           <a:stretch>
             <a:fillRect/>
           </a:stretch>
@@ -1970,7 +1984,7 @@
         <p:spPr>
           <a:xfrm>
             <a:off x="4645152" y="1426464"/>
-            <a:ext cx="4114800" cy="5440680"/>
+            <a:ext cx="4114800" cy="3886200"/>
           </a:xfrm>
           <a:prstGeom prst="rect">
             <a:avLst/>
@@ -1979,7 +1993,7 @@
       </p:pic>
       <p:pic>
         <p:nvPicPr>
-          <p:cNvPr id="6" name="" descr=""/>
+          <p:cNvPr id="6" name="Content Placeholder 5"/>
           <p:cNvPicPr>
             <a:picLocks noGrp="1"/>
           </p:cNvPicPr>
@@ -1988,7 +2002,601 @@
           </p:nvPr>
         </p:nvPicPr>
         <p:blipFill>
-          <a:blip cstate="print" r:embed="rId3"/>
+          <a:blip r:embed="rId3" cstate="print"/>
+          <a:stretch>
+            <a:fillRect/>
+          </a:stretch>
+        </p:blipFill>
+        <p:spPr>
+          <a:xfrm>
+            <a:off x="457200" y="1426464"/>
+            <a:ext cx="4114800" cy="3886200"/>
+          </a:xfrm>
+          <a:prstGeom prst="rect">
+            <a:avLst/>
+          </a:prstGeom>
+        </p:spPr>
+      </p:pic>
+    </p:spTree>
+  </p:cSld>
+  <p:clrMapOvr>
+    <a:masterClrMapping/>
+  </p:clrMapOvr>
+</p:sld>
+</file>
+
+<file path=ppt/slides/slide11.xml><?xml version="1.0" encoding="utf-8"?>
+<p:sld xmlns:a="http://schemas.openxmlformats.org/drawingml/2006/main" xmlns:r="http://schemas.openxmlformats.org/officeDocument/2006/relationships" xmlns:p="http://schemas.openxmlformats.org/presentationml/2006/main">
+  <p:cSld>
+    <p:spTree>
+      <p:nvGrpSpPr>
+        <p:cNvPr id="1" name=""/>
+        <p:cNvGrpSpPr/>
+        <p:nvPr/>
+      </p:nvGrpSpPr>
+      <p:grpSpPr>
+        <a:xfrm>
+          <a:off x="0" y="0"/>
+          <a:ext cx="0" cy="0"/>
+          <a:chOff x="0" y="0"/>
+          <a:chExt cx="0" cy="0"/>
+        </a:xfrm>
+      </p:grpSpPr>
+      <p:sp>
+        <p:nvSpPr>
+          <p:cNvPr id="2" name="Title 1"/>
+          <p:cNvSpPr>
+            <a:spLocks noGrp="1"/>
+          </p:cNvSpPr>
+          <p:nvPr>
+            <p:ph type="title"/>
+          </p:nvPr>
+        </p:nvSpPr>
+        <p:spPr>
+          <a:xfrm>
+            <a:off x="457200" y="6283"/>
+            <a:ext cx="8229600" cy="659640"/>
+          </a:xfrm>
+        </p:spPr>
+        <p:txBody>
+          <a:bodyPr/>
+          <a:lstStyle/>
+          <a:p>
+            <a:r>
+              <a:t>Comparison HFDDam_over_RDDam</a:t>
+            </a:r>
+          </a:p>
+        </p:txBody>
+      </p:sp>
+      <p:sp>
+        <p:nvSpPr>
+          <p:cNvPr id="3" name="Text Placeholder 4"/>
+          <p:cNvSpPr>
+            <a:spLocks noGrp="1"/>
+          </p:cNvSpPr>
+          <p:nvPr>
+            <p:ph type="body" sz="quarter" idx="3"/>
+          </p:nvPr>
+        </p:nvSpPr>
+        <p:spPr>
+          <a:xfrm>
+            <a:off x="4645025" y="782905"/>
+            <a:ext cx="4041775" cy="639762"/>
+          </a:xfrm>
+        </p:spPr>
+        <p:txBody>
+          <a:bodyPr/>
+          <a:lstStyle/>
+          <a:p>
+            <a:r>
+              <a:t>Differential FDR&lt;0.25</a:t>
+            </a:r>
+          </a:p>
+        </p:txBody>
+      </p:sp>
+      <p:sp>
+        <p:nvSpPr>
+          <p:cNvPr id="4" name="Text Placeholder 2"/>
+          <p:cNvSpPr>
+            <a:spLocks noGrp="1"/>
+          </p:cNvSpPr>
+          <p:nvPr>
+            <p:ph type="body" idx="1"/>
+          </p:nvPr>
+        </p:nvSpPr>
+        <p:spPr>
+          <a:xfrm>
+            <a:off x="457200" y="776118"/>
+            <a:ext cx="4040188" cy="639762"/>
+          </a:xfrm>
+        </p:spPr>
+        <p:txBody>
+          <a:bodyPr/>
+          <a:lstStyle/>
+          <a:p>
+            <a:r>
+              <a:t>Complete Set FDR=1</a:t>
+            </a:r>
+          </a:p>
+        </p:txBody>
+      </p:sp>
+      <p:pic>
+        <p:nvPicPr>
+          <p:cNvPr id="5" name="Content Placeholder 4"/>
+          <p:cNvPicPr>
+            <a:picLocks noGrp="1"/>
+          </p:cNvPicPr>
+          <p:nvPr>
+            <p:ph/>
+          </p:nvPr>
+        </p:nvPicPr>
+        <p:blipFill>
+          <a:blip r:embed="rId2" cstate="print"/>
+          <a:stretch>
+            <a:fillRect/>
+          </a:stretch>
+        </p:blipFill>
+        <p:spPr>
+          <a:xfrm>
+            <a:off x="4645152" y="1426464"/>
+            <a:ext cx="4114800" cy="5440680"/>
+          </a:xfrm>
+          <a:prstGeom prst="rect">
+            <a:avLst/>
+          </a:prstGeom>
+        </p:spPr>
+      </p:pic>
+      <p:pic>
+        <p:nvPicPr>
+          <p:cNvPr id="6" name="Content Placeholder 5"/>
+          <p:cNvPicPr>
+            <a:picLocks noGrp="1"/>
+          </p:cNvPicPr>
+          <p:nvPr>
+            <p:ph/>
+          </p:nvPr>
+        </p:nvPicPr>
+        <p:blipFill>
+          <a:blip r:embed="rId3" cstate="print"/>
+          <a:stretch>
+            <a:fillRect/>
+          </a:stretch>
+        </p:blipFill>
+        <p:spPr>
+          <a:xfrm>
+            <a:off x="457200" y="1426464"/>
+            <a:ext cx="4114800" cy="5440680"/>
+          </a:xfrm>
+          <a:prstGeom prst="rect">
+            <a:avLst/>
+          </a:prstGeom>
+        </p:spPr>
+      </p:pic>
+    </p:spTree>
+  </p:cSld>
+  <p:clrMapOvr>
+    <a:masterClrMapping/>
+  </p:clrMapOvr>
+</p:sld>
+</file>
+
+<file path=ppt/slides/slide12.xml><?xml version="1.0" encoding="utf-8"?>
+<p:sld xmlns:a="http://schemas.openxmlformats.org/drawingml/2006/main" xmlns:r="http://schemas.openxmlformats.org/officeDocument/2006/relationships" xmlns:p="http://schemas.openxmlformats.org/presentationml/2006/main">
+  <p:cSld>
+    <p:spTree>
+      <p:nvGrpSpPr>
+        <p:cNvPr id="1" name=""/>
+        <p:cNvGrpSpPr/>
+        <p:nvPr/>
+      </p:nvGrpSpPr>
+      <p:grpSpPr>
+        <a:xfrm>
+          <a:off x="0" y="0"/>
+          <a:ext cx="0" cy="0"/>
+          <a:chOff x="0" y="0"/>
+          <a:chExt cx="0" cy="0"/>
+        </a:xfrm>
+      </p:grpSpPr>
+      <p:sp>
+        <p:nvSpPr>
+          <p:cNvPr id="2" name="Title 1"/>
+          <p:cNvSpPr>
+            <a:spLocks noGrp="1"/>
+          </p:cNvSpPr>
+          <p:nvPr>
+            <p:ph type="title"/>
+          </p:nvPr>
+        </p:nvSpPr>
+        <p:spPr>
+          <a:xfrm>
+            <a:off x="457200" y="6283"/>
+            <a:ext cx="8229600" cy="659640"/>
+          </a:xfrm>
+        </p:spPr>
+        <p:txBody>
+          <a:bodyPr/>
+          <a:lstStyle/>
+          <a:p>
+            <a:r>
+              <a:t>Comparison MaleMHFD_over_MaleMRD</a:t>
+            </a:r>
+          </a:p>
+        </p:txBody>
+      </p:sp>
+      <p:sp>
+        <p:nvSpPr>
+          <p:cNvPr id="3" name="Text Placeholder 4"/>
+          <p:cNvSpPr>
+            <a:spLocks noGrp="1"/>
+          </p:cNvSpPr>
+          <p:nvPr>
+            <p:ph type="body" sz="quarter" idx="3"/>
+          </p:nvPr>
+        </p:nvSpPr>
+        <p:spPr>
+          <a:xfrm>
+            <a:off x="4645025" y="782905"/>
+            <a:ext cx="4041775" cy="639762"/>
+          </a:xfrm>
+        </p:spPr>
+        <p:txBody>
+          <a:bodyPr/>
+          <a:lstStyle/>
+          <a:p>
+            <a:r>
+              <a:t>Differential FDR&lt;0.25</a:t>
+            </a:r>
+          </a:p>
+        </p:txBody>
+      </p:sp>
+      <p:sp>
+        <p:nvSpPr>
+          <p:cNvPr id="4" name="Text Placeholder 2"/>
+          <p:cNvSpPr>
+            <a:spLocks noGrp="1"/>
+          </p:cNvSpPr>
+          <p:nvPr>
+            <p:ph type="body" idx="1"/>
+          </p:nvPr>
+        </p:nvSpPr>
+        <p:spPr>
+          <a:xfrm>
+            <a:off x="457200" y="776118"/>
+            <a:ext cx="4040188" cy="639762"/>
+          </a:xfrm>
+        </p:spPr>
+        <p:txBody>
+          <a:bodyPr/>
+          <a:lstStyle/>
+          <a:p>
+            <a:r>
+              <a:t>Complete Set FDR=1</a:t>
+            </a:r>
+          </a:p>
+        </p:txBody>
+      </p:sp>
+      <p:pic>
+        <p:nvPicPr>
+          <p:cNvPr id="5" name="Content Placeholder 4"/>
+          <p:cNvPicPr>
+            <a:picLocks noGrp="1"/>
+          </p:cNvPicPr>
+          <p:nvPr>
+            <p:ph/>
+          </p:nvPr>
+        </p:nvPicPr>
+        <p:blipFill>
+          <a:blip r:embed="rId2" cstate="print"/>
+          <a:stretch>
+            <a:fillRect/>
+          </a:stretch>
+        </p:blipFill>
+        <p:spPr>
+          <a:xfrm>
+            <a:off x="4645152" y="1426464"/>
+            <a:ext cx="4114800" cy="5440680"/>
+          </a:xfrm>
+          <a:prstGeom prst="rect">
+            <a:avLst/>
+          </a:prstGeom>
+        </p:spPr>
+      </p:pic>
+      <p:pic>
+        <p:nvPicPr>
+          <p:cNvPr id="6" name="Content Placeholder 5"/>
+          <p:cNvPicPr>
+            <a:picLocks noGrp="1"/>
+          </p:cNvPicPr>
+          <p:nvPr>
+            <p:ph/>
+          </p:nvPr>
+        </p:nvPicPr>
+        <p:blipFill>
+          <a:blip r:embed="rId3" cstate="print"/>
+          <a:stretch>
+            <a:fillRect/>
+          </a:stretch>
+        </p:blipFill>
+        <p:spPr>
+          <a:xfrm>
+            <a:off x="457200" y="1426464"/>
+            <a:ext cx="4114800" cy="5440680"/>
+          </a:xfrm>
+          <a:prstGeom prst="rect">
+            <a:avLst/>
+          </a:prstGeom>
+        </p:spPr>
+      </p:pic>
+    </p:spTree>
+  </p:cSld>
+  <p:clrMapOvr>
+    <a:masterClrMapping/>
+  </p:clrMapOvr>
+</p:sld>
+</file>
+
+<file path=ppt/slides/slide13.xml><?xml version="1.0" encoding="utf-8"?>
+<p:sld xmlns:a="http://schemas.openxmlformats.org/drawingml/2006/main" xmlns:r="http://schemas.openxmlformats.org/officeDocument/2006/relationships" xmlns:p="http://schemas.openxmlformats.org/presentationml/2006/main">
+  <p:cSld>
+    <p:spTree>
+      <p:nvGrpSpPr>
+        <p:cNvPr id="1" name=""/>
+        <p:cNvGrpSpPr/>
+        <p:nvPr/>
+      </p:nvGrpSpPr>
+      <p:grpSpPr>
+        <a:xfrm>
+          <a:off x="0" y="0"/>
+          <a:ext cx="0" cy="0"/>
+          <a:chOff x="0" y="0"/>
+          <a:chExt cx="0" cy="0"/>
+        </a:xfrm>
+      </p:grpSpPr>
+      <p:sp>
+        <p:nvSpPr>
+          <p:cNvPr id="2" name="Title 1"/>
+          <p:cNvSpPr>
+            <a:spLocks noGrp="1"/>
+          </p:cNvSpPr>
+          <p:nvPr>
+            <p:ph type="title"/>
+          </p:nvPr>
+        </p:nvSpPr>
+        <p:spPr>
+          <a:xfrm>
+            <a:off x="457200" y="6283"/>
+            <a:ext cx="8229600" cy="659640"/>
+          </a:xfrm>
+        </p:spPr>
+        <p:txBody>
+          <a:bodyPr/>
+          <a:lstStyle/>
+          <a:p>
+            <a:r>
+              <a:t>Comparison FemMHFD_over_FemMRD</a:t>
+            </a:r>
+          </a:p>
+        </p:txBody>
+      </p:sp>
+      <p:sp>
+        <p:nvSpPr>
+          <p:cNvPr id="3" name="Text Placeholder 4"/>
+          <p:cNvSpPr>
+            <a:spLocks noGrp="1"/>
+          </p:cNvSpPr>
+          <p:nvPr>
+            <p:ph type="body" sz="quarter" idx="3"/>
+          </p:nvPr>
+        </p:nvSpPr>
+        <p:spPr>
+          <a:xfrm>
+            <a:off x="4645025" y="782905"/>
+            <a:ext cx="4041775" cy="639762"/>
+          </a:xfrm>
+        </p:spPr>
+        <p:txBody>
+          <a:bodyPr/>
+          <a:lstStyle/>
+          <a:p>
+            <a:r>
+              <a:t>Differential FDR&lt;0.25</a:t>
+            </a:r>
+          </a:p>
+        </p:txBody>
+      </p:sp>
+      <p:sp>
+        <p:nvSpPr>
+          <p:cNvPr id="4" name="Text Placeholder 2"/>
+          <p:cNvSpPr>
+            <a:spLocks noGrp="1"/>
+          </p:cNvSpPr>
+          <p:nvPr>
+            <p:ph type="body" idx="1"/>
+          </p:nvPr>
+        </p:nvSpPr>
+        <p:spPr>
+          <a:xfrm>
+            <a:off x="457200" y="776118"/>
+            <a:ext cx="4040188" cy="639762"/>
+          </a:xfrm>
+        </p:spPr>
+        <p:txBody>
+          <a:bodyPr/>
+          <a:lstStyle/>
+          <a:p>
+            <a:r>
+              <a:t>Complete Set FDR=1</a:t>
+            </a:r>
+          </a:p>
+        </p:txBody>
+      </p:sp>
+      <p:pic>
+        <p:nvPicPr>
+          <p:cNvPr id="5" name="Content Placeholder 4"/>
+          <p:cNvPicPr>
+            <a:picLocks noGrp="1"/>
+          </p:cNvPicPr>
+          <p:nvPr>
+            <p:ph/>
+          </p:nvPr>
+        </p:nvPicPr>
+        <p:blipFill>
+          <a:blip r:embed="rId2" cstate="print"/>
+          <a:stretch>
+            <a:fillRect/>
+          </a:stretch>
+        </p:blipFill>
+        <p:spPr>
+          <a:xfrm>
+            <a:off x="457200" y="1426464"/>
+            <a:ext cx="4114800" cy="5440680"/>
+          </a:xfrm>
+          <a:prstGeom prst="rect">
+            <a:avLst/>
+          </a:prstGeom>
+        </p:spPr>
+      </p:pic>
+    </p:spTree>
+  </p:cSld>
+  <p:clrMapOvr>
+    <a:masterClrMapping/>
+  </p:clrMapOvr>
+</p:sld>
+</file>
+
+<file path=ppt/slides/slide14.xml><?xml version="1.0" encoding="utf-8"?>
+<p:sld xmlns:a="http://schemas.openxmlformats.org/drawingml/2006/main" xmlns:r="http://schemas.openxmlformats.org/officeDocument/2006/relationships" xmlns:p="http://schemas.openxmlformats.org/presentationml/2006/main">
+  <p:cSld>
+    <p:spTree>
+      <p:nvGrpSpPr>
+        <p:cNvPr id="1" name=""/>
+        <p:cNvGrpSpPr/>
+        <p:nvPr/>
+      </p:nvGrpSpPr>
+      <p:grpSpPr>
+        <a:xfrm>
+          <a:off x="0" y="0"/>
+          <a:ext cx="0" cy="0"/>
+          <a:chOff x="0" y="0"/>
+          <a:chExt cx="0" cy="0"/>
+        </a:xfrm>
+      </p:grpSpPr>
+      <p:sp>
+        <p:nvSpPr>
+          <p:cNvPr id="2" name="Title 1"/>
+          <p:cNvSpPr>
+            <a:spLocks noGrp="1"/>
+          </p:cNvSpPr>
+          <p:nvPr>
+            <p:ph type="title"/>
+          </p:nvPr>
+        </p:nvSpPr>
+        <p:spPr>
+          <a:xfrm>
+            <a:off x="457200" y="6283"/>
+            <a:ext cx="8229600" cy="659640"/>
+          </a:xfrm>
+        </p:spPr>
+        <p:txBody>
+          <a:bodyPr/>
+          <a:lstStyle/>
+          <a:p>
+            <a:r>
+              <a:t>Comparison RDDam_HFDDam_MaleMRD_MaleMHFD_FemMRD_FemMHFD</a:t>
+            </a:r>
+          </a:p>
+        </p:txBody>
+      </p:sp>
+      <p:sp>
+        <p:nvSpPr>
+          <p:cNvPr id="3" name="Text Placeholder 4"/>
+          <p:cNvSpPr>
+            <a:spLocks noGrp="1"/>
+          </p:cNvSpPr>
+          <p:nvPr>
+            <p:ph type="body" sz="quarter" idx="3"/>
+          </p:nvPr>
+        </p:nvSpPr>
+        <p:spPr>
+          <a:xfrm>
+            <a:off x="4645025" y="782905"/>
+            <a:ext cx="4041775" cy="639762"/>
+          </a:xfrm>
+        </p:spPr>
+        <p:txBody>
+          <a:bodyPr/>
+          <a:lstStyle/>
+          <a:p>
+            <a:r>
+              <a:t>Differential FDR&lt;0.25</a:t>
+            </a:r>
+          </a:p>
+        </p:txBody>
+      </p:sp>
+      <p:sp>
+        <p:nvSpPr>
+          <p:cNvPr id="4" name="Text Placeholder 2"/>
+          <p:cNvSpPr>
+            <a:spLocks noGrp="1"/>
+          </p:cNvSpPr>
+          <p:nvPr>
+            <p:ph type="body" idx="1"/>
+          </p:nvPr>
+        </p:nvSpPr>
+        <p:spPr>
+          <a:xfrm>
+            <a:off x="457200" y="776118"/>
+            <a:ext cx="4040188" cy="639762"/>
+          </a:xfrm>
+        </p:spPr>
+        <p:txBody>
+          <a:bodyPr/>
+          <a:lstStyle/>
+          <a:p>
+            <a:r>
+              <a:t>Complete Set FDR=1</a:t>
+            </a:r>
+          </a:p>
+        </p:txBody>
+      </p:sp>
+      <p:pic>
+        <p:nvPicPr>
+          <p:cNvPr id="5" name="Content Placeholder 4"/>
+          <p:cNvPicPr>
+            <a:picLocks noGrp="1"/>
+          </p:cNvPicPr>
+          <p:nvPr>
+            <p:ph/>
+          </p:nvPr>
+        </p:nvPicPr>
+        <p:blipFill>
+          <a:blip r:embed="rId2" cstate="print"/>
+          <a:stretch>
+            <a:fillRect/>
+          </a:stretch>
+        </p:blipFill>
+        <p:spPr>
+          <a:xfrm>
+            <a:off x="4645152" y="1426464"/>
+            <a:ext cx="4114800" cy="5440680"/>
+          </a:xfrm>
+          <a:prstGeom prst="rect">
+            <a:avLst/>
+          </a:prstGeom>
+        </p:spPr>
+      </p:pic>
+      <p:pic>
+        <p:nvPicPr>
+          <p:cNvPr id="6" name="Content Placeholder 5"/>
+          <p:cNvPicPr>
+            <a:picLocks noGrp="1"/>
+          </p:cNvPicPr>
+          <p:nvPr>
+            <p:ph/>
+          </p:nvPr>
+        </p:nvPicPr>
+        <p:blipFill>
+          <a:blip r:embed="rId3" cstate="print"/>
           <a:stretch>
             <a:fillRect/>
           </a:stretch>
@@ -2049,7 +2657,6 @@
           <a:lstStyle/>
           <a:p>
             <a:r>
-              <a:rPr/>
               <a:t>Project Overview</a:t>
             </a:r>
           </a:p>
@@ -2072,91 +2679,104 @@
           </a:xfrm>
         </p:spPr>
         <p:txBody>
-          <a:bodyPr/>
+          <a:bodyPr>
+            <a:normAutofit fontScale="92500" lnSpcReduction="20000"/>
+          </a:bodyPr>
           <a:lstStyle/>
           <a:p>
-            <a:pPr/>
-            <a:r>
-              <a:rPr/>
+            <a:r>
+              <a:rPr dirty="0"/>
               <a:t>Samples</a:t>
             </a:r>
+            <a:r>
+              <a:rPr lang="en-US" dirty="0"/>
+              <a:t> </a:t>
+            </a:r>
+            <a:endParaRPr dirty="0"/>
           </a:p>
           <a:p>
             <a:pPr lvl="1"/>
             <a:r>
-              <a:rPr/>
+              <a:rPr dirty="0"/>
               <a:t>39 experimental samples</a:t>
             </a:r>
           </a:p>
           <a:p>
             <a:pPr lvl="1"/>
             <a:r>
-              <a:rPr/>
+              <a:rPr dirty="0"/>
               <a:t>3 liver control samples</a:t>
             </a:r>
           </a:p>
           <a:p>
-            <a:pPr/>
-            <a:r>
-              <a:rPr/>
+            <a:r>
+              <a:rPr dirty="0"/>
               <a:t>Total of 23 features from 1 methods</a:t>
             </a:r>
           </a:p>
           <a:p>
             <a:pPr lvl="1"/>
             <a:r>
-              <a:rPr/>
-              <a:t>AminoAcids was normalized by Internal Standard L-Tryptophan (ISTD) [CV = 0.05]</a:t>
-            </a:r>
-          </a:p>
-          <a:p>
-            <a:pPr/>
-            <a:r>
-              <a:rPr/>
+              <a:rPr dirty="0" err="1"/>
+              <a:t>AminoAcids</a:t>
+            </a:r>
+            <a:r>
+              <a:rPr dirty="0"/>
+              <a:t> was normalized by Internal Standard L-Tryptophan (ISTD) [CV = 0.05]</a:t>
+            </a:r>
+          </a:p>
+          <a:p>
+            <a:r>
+              <a:rPr dirty="0"/>
               <a:t>Comparisons performed</a:t>
             </a:r>
           </a:p>
           <a:p>
             <a:pPr lvl="1"/>
             <a:r>
-              <a:rPr/>
+              <a:rPr dirty="0"/>
               <a:t>t-test</a:t>
             </a:r>
           </a:p>
           <a:p>
             <a:pPr lvl="2"/>
             <a:r>
-              <a:rPr/>
+              <a:rPr dirty="0" err="1"/>
               <a:t>HFDDam_over_RDDam</a:t>
             </a:r>
+            <a:endParaRPr dirty="0"/>
           </a:p>
           <a:p>
             <a:pPr lvl="2"/>
             <a:r>
-              <a:rPr/>
+              <a:rPr dirty="0" err="1"/>
               <a:t>MaleMHFD_over_MaleMRD</a:t>
             </a:r>
+            <a:endParaRPr dirty="0"/>
           </a:p>
           <a:p>
             <a:pPr lvl="2"/>
             <a:r>
-              <a:rPr/>
+              <a:rPr dirty="0" err="1"/>
               <a:t>FemMHFD_over_FemMRD</a:t>
             </a:r>
+            <a:endParaRPr dirty="0"/>
           </a:p>
           <a:p>
             <a:pPr lvl="1"/>
             <a:r>
-              <a:rPr/>
+              <a:rPr dirty="0" err="1"/>
               <a:t>anova</a:t>
             </a:r>
+            <a:endParaRPr dirty="0"/>
           </a:p>
           <a:p>
             <a:pPr lvl="2"/>
             <a:r>
-              <a:rPr/>
-              <a:t>MaleMRD_MaleMHFD_FemMRD_FemMHFD</a:t>
-            </a:r>
+              <a:rPr dirty="0" err="1"/>
+              <a:t>RDDam_HFDDam_MaleMRD_MaleMHFD_FemMRD_FemMHFD</a:t>
+            </a:r>
+            <a:endParaRPr dirty="0"/>
           </a:p>
         </p:txBody>
       </p:sp>
@@ -2206,7 +2826,6 @@
           <a:lstStyle/>
           <a:p>
             <a:r>
-              <a:rPr/>
               <a:t>QA plots: all_samples</a:t>
             </a:r>
           </a:p>
@@ -2214,7 +2833,7 @@
       </p:sp>
       <p:pic>
         <p:nvPicPr>
-          <p:cNvPr id="3" name="" descr=""/>
+          <p:cNvPr id="3" name="Content Placeholder 2"/>
           <p:cNvPicPr>
             <a:picLocks noGrp="1"/>
           </p:cNvPicPr>
@@ -2223,7 +2842,7 @@
           </p:nvPr>
         </p:nvPicPr>
         <p:blipFill>
-          <a:blip cstate="print" r:embed="rId2"/>
+          <a:blip r:embed="rId2" cstate="print"/>
           <a:stretch>
             <a:fillRect/>
           </a:stretch>
@@ -2284,7 +2903,6 @@
           <a:lstStyle/>
           <a:p>
             <a:r>
-              <a:rPr/>
               <a:t>QA plots: AminoAcids</a:t>
             </a:r>
           </a:p>
@@ -2292,7 +2910,7 @@
       </p:sp>
       <p:pic>
         <p:nvPicPr>
-          <p:cNvPr id="3" name="" descr=""/>
+          <p:cNvPr id="3" name="Content Placeholder 2"/>
           <p:cNvPicPr>
             <a:picLocks noGrp="1"/>
           </p:cNvPicPr>
@@ -2301,7 +2919,7 @@
           </p:nvPr>
         </p:nvPicPr>
         <p:blipFill>
-          <a:blip cstate="print" r:embed="rId2"/>
+          <a:blip r:embed="rId2" cstate="print"/>
           <a:stretch>
             <a:fillRect/>
           </a:stretch>
@@ -2362,7 +2980,6 @@
           <a:lstStyle/>
           <a:p>
             <a:r>
-              <a:rPr/>
               <a:t>Liver Control: AminoAcids</a:t>
             </a:r>
           </a:p>
@@ -2370,7 +2987,7 @@
       </p:sp>
       <p:pic>
         <p:nvPicPr>
-          <p:cNvPr id="3" name="" descr=""/>
+          <p:cNvPr id="3" name="Content Placeholder 2"/>
           <p:cNvPicPr>
             <a:picLocks noGrp="1"/>
           </p:cNvPicPr>
@@ -2379,7 +2996,7 @@
           </p:nvPr>
         </p:nvPicPr>
         <p:blipFill>
-          <a:blip cstate="print" r:embed="rId2"/>
+          <a:blip r:embed="rId2" cstate="print"/>
           <a:stretch>
             <a:fillRect/>
           </a:stretch>
@@ -2440,7 +3057,6 @@
           <a:lstStyle/>
           <a:p>
             <a:r>
-              <a:rPr/>
               <a:t>Internal Standards Distribution: AminoAcids</a:t>
             </a:r>
           </a:p>
@@ -2448,7 +3064,7 @@
       </p:sp>
       <p:pic>
         <p:nvPicPr>
-          <p:cNvPr id="3" name="" descr=""/>
+          <p:cNvPr id="3" name="Content Placeholder 2"/>
           <p:cNvPicPr>
             <a:picLocks noGrp="1"/>
           </p:cNvPicPr>
@@ -2457,7 +3073,7 @@
           </p:nvPr>
         </p:nvPicPr>
         <p:blipFill>
-          <a:blip cstate="print" r:embed="rId2"/>
+          <a:blip r:embed="rId2" cstate="print"/>
           <a:stretch>
             <a:fillRect/>
           </a:stretch>
@@ -2518,7 +3134,6 @@
           <a:lstStyle/>
           <a:p>
             <a:r>
-              <a:rPr/>
               <a:t>Comparison HFDDam_over_RDDam</a:t>
             </a:r>
           </a:p>
@@ -2545,8 +3160,7 @@
           <a:lstStyle/>
           <a:p>
             <a:r>
-              <a:rPr/>
-              <a:t>Differential FDR&lt;0.25</a:t>
+              <a:t>Normalized PCA</a:t>
             </a:r>
           </a:p>
         </p:txBody>
@@ -2572,15 +3186,14 @@
           <a:lstStyle/>
           <a:p>
             <a:r>
-              <a:rPr/>
-              <a:t>Complete Set FDR=1</a:t>
+              <a:t>Raw PCA</a:t>
             </a:r>
           </a:p>
         </p:txBody>
       </p:sp>
       <p:pic>
         <p:nvPicPr>
-          <p:cNvPr id="5" name="" descr=""/>
+          <p:cNvPr id="5" name="Content Placeholder 4"/>
           <p:cNvPicPr>
             <a:picLocks noGrp="1"/>
           </p:cNvPicPr>
@@ -2589,7 +3202,7 @@
           </p:nvPr>
         </p:nvPicPr>
         <p:blipFill>
-          <a:blip cstate="print" r:embed="rId2"/>
+          <a:blip r:embed="rId2" cstate="print"/>
           <a:stretch>
             <a:fillRect/>
           </a:stretch>
@@ -2597,7 +3210,7 @@
         <p:spPr>
           <a:xfrm>
             <a:off x="4645152" y="1426464"/>
-            <a:ext cx="4114800" cy="5440680"/>
+            <a:ext cx="4114800" cy="3886200"/>
           </a:xfrm>
           <a:prstGeom prst="rect">
             <a:avLst/>
@@ -2606,7 +3219,7 @@
       </p:pic>
       <p:pic>
         <p:nvPicPr>
-          <p:cNvPr id="6" name="" descr=""/>
+          <p:cNvPr id="6" name="Content Placeholder 5"/>
           <p:cNvPicPr>
             <a:picLocks noGrp="1"/>
           </p:cNvPicPr>
@@ -2615,7 +3228,7 @@
           </p:nvPr>
         </p:nvPicPr>
         <p:blipFill>
-          <a:blip cstate="print" r:embed="rId3"/>
+          <a:blip r:embed="rId3" cstate="print"/>
           <a:stretch>
             <a:fillRect/>
           </a:stretch>
@@ -2623,7 +3236,7 @@
         <p:spPr>
           <a:xfrm>
             <a:off x="457200" y="1426464"/>
-            <a:ext cx="4114800" cy="5440680"/>
+            <a:ext cx="4114800" cy="3886200"/>
           </a:xfrm>
           <a:prstGeom prst="rect">
             <a:avLst/>
@@ -2676,7 +3289,6 @@
           <a:lstStyle/>
           <a:p>
             <a:r>
-              <a:rPr/>
               <a:t>Comparison MaleMHFD_over_MaleMRD</a:t>
             </a:r>
           </a:p>
@@ -2703,8 +3315,7 @@
           <a:lstStyle/>
           <a:p>
             <a:r>
-              <a:rPr/>
-              <a:t>Differential FDR&lt;0.25</a:t>
+              <a:t>Normalized PCA</a:t>
             </a:r>
           </a:p>
         </p:txBody>
@@ -2730,15 +3341,14 @@
           <a:lstStyle/>
           <a:p>
             <a:r>
-              <a:rPr/>
-              <a:t>Complete Set FDR=1</a:t>
+              <a:t>Raw PCA</a:t>
             </a:r>
           </a:p>
         </p:txBody>
       </p:sp>
       <p:pic>
         <p:nvPicPr>
-          <p:cNvPr id="5" name="" descr=""/>
+          <p:cNvPr id="5" name="Content Placeholder 4"/>
           <p:cNvPicPr>
             <a:picLocks noGrp="1"/>
           </p:cNvPicPr>
@@ -2747,7 +3357,7 @@
           </p:nvPr>
         </p:nvPicPr>
         <p:blipFill>
-          <a:blip cstate="print" r:embed="rId2"/>
+          <a:blip r:embed="rId2" cstate="print"/>
           <a:stretch>
             <a:fillRect/>
           </a:stretch>
@@ -2755,7 +3365,7 @@
         <p:spPr>
           <a:xfrm>
             <a:off x="4645152" y="1426464"/>
-            <a:ext cx="4114800" cy="5440680"/>
+            <a:ext cx="4114800" cy="3886200"/>
           </a:xfrm>
           <a:prstGeom prst="rect">
             <a:avLst/>
@@ -2764,7 +3374,7 @@
       </p:pic>
       <p:pic>
         <p:nvPicPr>
-          <p:cNvPr id="6" name="" descr=""/>
+          <p:cNvPr id="6" name="Content Placeholder 5"/>
           <p:cNvPicPr>
             <a:picLocks noGrp="1"/>
           </p:cNvPicPr>
@@ -2773,7 +3383,7 @@
           </p:nvPr>
         </p:nvPicPr>
         <p:blipFill>
-          <a:blip cstate="print" r:embed="rId3"/>
+          <a:blip r:embed="rId3" cstate="print"/>
           <a:stretch>
             <a:fillRect/>
           </a:stretch>
@@ -2781,7 +3391,7 @@
         <p:spPr>
           <a:xfrm>
             <a:off x="457200" y="1426464"/>
-            <a:ext cx="4114800" cy="5440680"/>
+            <a:ext cx="4114800" cy="3886200"/>
           </a:xfrm>
           <a:prstGeom prst="rect">
             <a:avLst/>
@@ -2834,7 +3444,6 @@
           <a:lstStyle/>
           <a:p>
             <a:r>
-              <a:rPr/>
               <a:t>Comparison FemMHFD_over_FemMRD</a:t>
             </a:r>
           </a:p>
@@ -2861,8 +3470,7 @@
           <a:lstStyle/>
           <a:p>
             <a:r>
-              <a:rPr/>
-              <a:t>Differential FDR&lt;0.25</a:t>
+              <a:t>Normalized PCA</a:t>
             </a:r>
           </a:p>
         </p:txBody>
@@ -2888,15 +3496,14 @@
           <a:lstStyle/>
           <a:p>
             <a:r>
-              <a:rPr/>
-              <a:t>Complete Set FDR=1</a:t>
+              <a:t>Raw PCA</a:t>
             </a:r>
           </a:p>
         </p:txBody>
       </p:sp>
       <p:pic>
         <p:nvPicPr>
-          <p:cNvPr id="5" name="" descr=""/>
+          <p:cNvPr id="5" name="Content Placeholder 4"/>
           <p:cNvPicPr>
             <a:picLocks noGrp="1"/>
           </p:cNvPicPr>
@@ -2905,15 +3512,41 @@
           </p:nvPr>
         </p:nvPicPr>
         <p:blipFill>
-          <a:blip cstate="print" r:embed="rId2"/>
+          <a:blip r:embed="rId2" cstate="print"/>
           <a:stretch>
             <a:fillRect/>
           </a:stretch>
         </p:blipFill>
         <p:spPr>
           <a:xfrm>
+            <a:off x="4645152" y="1426464"/>
+            <a:ext cx="4114800" cy="3886200"/>
+          </a:xfrm>
+          <a:prstGeom prst="rect">
+            <a:avLst/>
+          </a:prstGeom>
+        </p:spPr>
+      </p:pic>
+      <p:pic>
+        <p:nvPicPr>
+          <p:cNvPr id="6" name="Content Placeholder 5"/>
+          <p:cNvPicPr>
+            <a:picLocks noGrp="1"/>
+          </p:cNvPicPr>
+          <p:nvPr>
+            <p:ph/>
+          </p:nvPr>
+        </p:nvPicPr>
+        <p:blipFill>
+          <a:blip r:embed="rId3" cstate="print"/>
+          <a:stretch>
+            <a:fillRect/>
+          </a:stretch>
+        </p:blipFill>
+        <p:spPr>
+          <a:xfrm>
             <a:off x="457200" y="1426464"/>
-            <a:ext cx="4114800" cy="5440680"/>
+            <a:ext cx="4114800" cy="3886200"/>
           </a:xfrm>
           <a:prstGeom prst="rect">
             <a:avLst/>

</xml_diff>

<commit_message>
updated comparisons file and results for all examples
</commit_message>
<xml_diff>
--- a/example1-metabolomics/results-A/report.pptx
+++ b/example1-metabolomics/results-A/report.pptx
@@ -5,26 +5,26 @@
     <p:sldMasterId id="2147483660" r:id="rId1"/>
   </p:sldMasterIdLst>
   <p:notesMasterIdLst>
-    <p:notesMasterId r:id="rId16"/>
+    <p:notesMasterId r:id="rId2"/>
   </p:notesMasterIdLst>
   <p:handoutMasterIdLst>
-    <p:handoutMasterId r:id="rId17"/>
+    <p:handoutMasterId r:id="rId3"/>
   </p:handoutMasterIdLst>
-  <p:sldIdLst>
-    <p:sldId id="256" r:id="rId2"/>
-    <p:sldId id="257" r:id="rId3"/>
-    <p:sldId id="258" r:id="rId4"/>
-    <p:sldId id="259" r:id="rId5"/>
-    <p:sldId id="260" r:id="rId6"/>
-    <p:sldId id="261" r:id="rId7"/>
-    <p:sldId id="262" r:id="rId8"/>
-    <p:sldId id="263" r:id="rId9"/>
-    <p:sldId id="264" r:id="rId10"/>
-    <p:sldId id="265" r:id="rId11"/>
-    <p:sldId id="266" r:id="rId12"/>
-    <p:sldId id="267" r:id="rId13"/>
-    <p:sldId id="268" r:id="rId14"/>
-    <p:sldId id="269" r:id="rId15"/>
+  <p:sldIdLst xmlns:a="http://schemas.openxmlformats.org/drawingml/2006/main" xmlns:r="http://schemas.openxmlformats.org/officeDocument/2006/relationships" xmlns:p="http://schemas.openxmlformats.org/presentationml/2006/main">
+    <p:sldId id="256" r:id="rId8"/>
+    <p:sldId id="257" r:id="rId9"/>
+    <p:sldId id="258" r:id="rId10"/>
+    <p:sldId id="259" r:id="rId11"/>
+    <p:sldId id="260" r:id="rId12"/>
+    <p:sldId id="261" r:id="rId13"/>
+    <p:sldId id="262" r:id="rId14"/>
+    <p:sldId id="263" r:id="rId15"/>
+    <p:sldId id="264" r:id="rId16"/>
+    <p:sldId id="265" r:id="rId17"/>
+    <p:sldId id="266" r:id="rId18"/>
+    <p:sldId id="267" r:id="rId19"/>
+    <p:sldId id="268" r:id="rId20"/>
+    <p:sldId id="269" r:id="rId21"/>
   </p:sldIdLst>
   <p:sldSz cx="9144000" cy="6858000" type="screen4x3"/>
   <p:notesSz cx="6858000" cy="9144000"/>
@@ -127,22 +127,7 @@
     <p:ext uri="{521415D9-36F7-43E2-AB2F-B90AF26B5E84}">
       <p14:sectionLst xmlns:p14="http://schemas.microsoft.com/office/powerpoint/2010/main">
         <p14:section name="Default Section" id="{23E95266-8A91-634B-9D8A-82E9C2DFC7E6}">
-          <p14:sldIdLst>
-            <p14:sldId id="256"/>
-            <p14:sldId id="257"/>
-            <p14:sldId id="258"/>
-            <p14:sldId id="259"/>
-            <p14:sldId id="260"/>
-            <p14:sldId id="261"/>
-            <p14:sldId id="262"/>
-            <p14:sldId id="263"/>
-            <p14:sldId id="264"/>
-            <p14:sldId id="265"/>
-            <p14:sldId id="266"/>
-            <p14:sldId id="267"/>
-            <p14:sldId id="268"/>
-            <p14:sldId id="269"/>
-          </p14:sldIdLst>
+          <p14:sldIdLst/>
         </p14:section>
       </p14:sectionLst>
     </p:ext>
@@ -246,7 +231,7 @@
           <a:p>
             <a:fld id="{12475388-B706-A848-A46B-DDB877936374}" type="datetimeFigureOut">
               <a:rPr lang="en-US" smtClean="0"/>
-              <a:t>3/29/23</a:t>
+              <a:t>1/29/18</a:t>
             </a:fld>
             <a:endParaRPr lang="en-US"/>
           </a:p>
@@ -412,7 +397,7 @@
           <a:p>
             <a:fld id="{A5587B2F-58BE-554B-B170-DCECE273C696}" type="datetimeFigureOut">
               <a:rPr lang="en-US" smtClean="0"/>
-              <a:t>3/29/23</a:t>
+              <a:t>1/29/18</a:t>
             </a:fld>
             <a:endParaRPr lang="en-US"/>
           </a:p>
@@ -1810,7 +1795,7 @@
           <a:chExt cx="0" cy="0"/>
         </a:xfrm>
       </p:grpSpPr>
-      <p:sp>
+      <p:sp xmlns:a="http://schemas.openxmlformats.org/drawingml/2006/main" xmlns:r="http://schemas.openxmlformats.org/officeDocument/2006/relationships" xmlns:p="http://schemas.openxmlformats.org/presentationml/2006/main">
         <p:nvSpPr>
           <p:cNvPr id="2" name="Title 1"/>
           <p:cNvSpPr>
@@ -1831,12 +1816,13 @@
           <a:lstStyle/>
           <a:p>
             <a:r>
+              <a:rPr/>
               <a:t>Project Report</a:t>
             </a:r>
           </a:p>
         </p:txBody>
       </p:sp>
-      <p:sp>
+      <p:sp xmlns:a="http://schemas.openxmlformats.org/drawingml/2006/main" xmlns:r="http://schemas.openxmlformats.org/officeDocument/2006/relationships" xmlns:p="http://schemas.openxmlformats.org/presentationml/2006/main">
         <p:nvSpPr>
           <p:cNvPr id="3" name="Subtitle 2"/>
           <p:cNvSpPr>
@@ -1857,6 +1843,7 @@
           <a:lstStyle/>
           <a:p>
             <a:r>
+              <a:rPr/>
               <a:t>Metabolomics Analysis</a:t>
             </a:r>
           </a:p>
@@ -1887,7 +1874,7 @@
           <a:chExt cx="0" cy="0"/>
         </a:xfrm>
       </p:grpSpPr>
-      <p:sp>
+      <p:sp xmlns:a="http://schemas.openxmlformats.org/drawingml/2006/main" xmlns:r="http://schemas.openxmlformats.org/officeDocument/2006/relationships" xmlns:p="http://schemas.openxmlformats.org/presentationml/2006/main">
         <p:nvSpPr>
           <p:cNvPr id="2" name="Title 1"/>
           <p:cNvSpPr>
@@ -1908,12 +1895,13 @@
           <a:lstStyle/>
           <a:p>
             <a:r>
+              <a:rPr/>
               <a:t>Comparison RDDam_HFDDam_MaleMRD_MaleMHFD_FemMRD_FemMHFD</a:t>
             </a:r>
           </a:p>
         </p:txBody>
       </p:sp>
-      <p:sp>
+      <p:sp xmlns:a="http://schemas.openxmlformats.org/drawingml/2006/main" xmlns:r="http://schemas.openxmlformats.org/officeDocument/2006/relationships" xmlns:p="http://schemas.openxmlformats.org/presentationml/2006/main">
         <p:nvSpPr>
           <p:cNvPr id="3" name="Text Placeholder 4"/>
           <p:cNvSpPr>
@@ -1934,12 +1922,13 @@
           <a:lstStyle/>
           <a:p>
             <a:r>
+              <a:rPr/>
               <a:t>Normalized PCA</a:t>
             </a:r>
           </a:p>
         </p:txBody>
       </p:sp>
-      <p:sp>
+      <p:sp xmlns:a="http://schemas.openxmlformats.org/drawingml/2006/main" xmlns:r="http://schemas.openxmlformats.org/officeDocument/2006/relationships" xmlns:p="http://schemas.openxmlformats.org/presentationml/2006/main">
         <p:nvSpPr>
           <p:cNvPr id="4" name="Text Placeholder 2"/>
           <p:cNvSpPr>
@@ -1960,14 +1949,15 @@
           <a:lstStyle/>
           <a:p>
             <a:r>
+              <a:rPr/>
               <a:t>Raw PCA</a:t>
             </a:r>
           </a:p>
         </p:txBody>
       </p:sp>
-      <p:pic>
+      <p:pic xmlns:a="http://schemas.openxmlformats.org/drawingml/2006/main" xmlns:r="http://schemas.openxmlformats.org/officeDocument/2006/relationships" xmlns:p="http://schemas.openxmlformats.org/presentationml/2006/main">
         <p:nvPicPr>
-          <p:cNvPr id="5" name="Content Placeholder 4"/>
+          <p:cNvPr id="5" name="" descr=""/>
           <p:cNvPicPr>
             <a:picLocks noGrp="1"/>
           </p:cNvPicPr>
@@ -1976,7 +1966,7 @@
           </p:nvPr>
         </p:nvPicPr>
         <p:blipFill>
-          <a:blip r:embed="rId2" cstate="print"/>
+          <a:blip cstate="print" r:embed="rId2"/>
           <a:stretch>
             <a:fillRect/>
           </a:stretch>
@@ -1991,9 +1981,9 @@
           </a:prstGeom>
         </p:spPr>
       </p:pic>
-      <p:pic>
+      <p:pic xmlns:a="http://schemas.openxmlformats.org/drawingml/2006/main" xmlns:r="http://schemas.openxmlformats.org/officeDocument/2006/relationships" xmlns:p="http://schemas.openxmlformats.org/presentationml/2006/main">
         <p:nvPicPr>
-          <p:cNvPr id="6" name="Content Placeholder 5"/>
+          <p:cNvPr id="6" name="" descr=""/>
           <p:cNvPicPr>
             <a:picLocks noGrp="1"/>
           </p:cNvPicPr>
@@ -2002,7 +1992,7 @@
           </p:nvPr>
         </p:nvPicPr>
         <p:blipFill>
-          <a:blip r:embed="rId3" cstate="print"/>
+          <a:blip cstate="print" r:embed="rId3"/>
           <a:stretch>
             <a:fillRect/>
           </a:stretch>
@@ -2042,7 +2032,7 @@
           <a:chExt cx="0" cy="0"/>
         </a:xfrm>
       </p:grpSpPr>
-      <p:sp>
+      <p:sp xmlns:a="http://schemas.openxmlformats.org/drawingml/2006/main" xmlns:r="http://schemas.openxmlformats.org/officeDocument/2006/relationships" xmlns:p="http://schemas.openxmlformats.org/presentationml/2006/main">
         <p:nvSpPr>
           <p:cNvPr id="2" name="Title 1"/>
           <p:cNvSpPr>
@@ -2063,12 +2053,13 @@
           <a:lstStyle/>
           <a:p>
             <a:r>
+              <a:rPr/>
               <a:t>Comparison HFDDam_over_RDDam</a:t>
             </a:r>
           </a:p>
         </p:txBody>
       </p:sp>
-      <p:sp>
+      <p:sp xmlns:a="http://schemas.openxmlformats.org/drawingml/2006/main" xmlns:r="http://schemas.openxmlformats.org/officeDocument/2006/relationships" xmlns:p="http://schemas.openxmlformats.org/presentationml/2006/main">
         <p:nvSpPr>
           <p:cNvPr id="3" name="Text Placeholder 4"/>
           <p:cNvSpPr>
@@ -2089,12 +2080,13 @@
           <a:lstStyle/>
           <a:p>
             <a:r>
+              <a:rPr/>
               <a:t>Differential FDR&lt;0.25</a:t>
             </a:r>
           </a:p>
         </p:txBody>
       </p:sp>
-      <p:sp>
+      <p:sp xmlns:a="http://schemas.openxmlformats.org/drawingml/2006/main" xmlns:r="http://schemas.openxmlformats.org/officeDocument/2006/relationships" xmlns:p="http://schemas.openxmlformats.org/presentationml/2006/main">
         <p:nvSpPr>
           <p:cNvPr id="4" name="Text Placeholder 2"/>
           <p:cNvSpPr>
@@ -2115,14 +2107,15 @@
           <a:lstStyle/>
           <a:p>
             <a:r>
+              <a:rPr/>
               <a:t>Complete Set FDR=1</a:t>
             </a:r>
           </a:p>
         </p:txBody>
       </p:sp>
-      <p:pic>
+      <p:pic xmlns:a="http://schemas.openxmlformats.org/drawingml/2006/main" xmlns:r="http://schemas.openxmlformats.org/officeDocument/2006/relationships" xmlns:p="http://schemas.openxmlformats.org/presentationml/2006/main">
         <p:nvPicPr>
-          <p:cNvPr id="5" name="Content Placeholder 4"/>
+          <p:cNvPr id="5" name="" descr=""/>
           <p:cNvPicPr>
             <a:picLocks noGrp="1"/>
           </p:cNvPicPr>
@@ -2131,7 +2124,7 @@
           </p:nvPr>
         </p:nvPicPr>
         <p:blipFill>
-          <a:blip r:embed="rId2" cstate="print"/>
+          <a:blip cstate="print" r:embed="rId2"/>
           <a:stretch>
             <a:fillRect/>
           </a:stretch>
@@ -2146,9 +2139,9 @@
           </a:prstGeom>
         </p:spPr>
       </p:pic>
-      <p:pic>
+      <p:pic xmlns:a="http://schemas.openxmlformats.org/drawingml/2006/main" xmlns:r="http://schemas.openxmlformats.org/officeDocument/2006/relationships" xmlns:p="http://schemas.openxmlformats.org/presentationml/2006/main">
         <p:nvPicPr>
-          <p:cNvPr id="6" name="Content Placeholder 5"/>
+          <p:cNvPr id="6" name="" descr=""/>
           <p:cNvPicPr>
             <a:picLocks noGrp="1"/>
           </p:cNvPicPr>
@@ -2157,7 +2150,7 @@
           </p:nvPr>
         </p:nvPicPr>
         <p:blipFill>
-          <a:blip r:embed="rId3" cstate="print"/>
+          <a:blip cstate="print" r:embed="rId3"/>
           <a:stretch>
             <a:fillRect/>
           </a:stretch>
@@ -2197,7 +2190,7 @@
           <a:chExt cx="0" cy="0"/>
         </a:xfrm>
       </p:grpSpPr>
-      <p:sp>
+      <p:sp xmlns:a="http://schemas.openxmlformats.org/drawingml/2006/main" xmlns:r="http://schemas.openxmlformats.org/officeDocument/2006/relationships" xmlns:p="http://schemas.openxmlformats.org/presentationml/2006/main">
         <p:nvSpPr>
           <p:cNvPr id="2" name="Title 1"/>
           <p:cNvSpPr>
@@ -2218,12 +2211,13 @@
           <a:lstStyle/>
           <a:p>
             <a:r>
+              <a:rPr/>
               <a:t>Comparison MaleMHFD_over_MaleMRD</a:t>
             </a:r>
           </a:p>
         </p:txBody>
       </p:sp>
-      <p:sp>
+      <p:sp xmlns:a="http://schemas.openxmlformats.org/drawingml/2006/main" xmlns:r="http://schemas.openxmlformats.org/officeDocument/2006/relationships" xmlns:p="http://schemas.openxmlformats.org/presentationml/2006/main">
         <p:nvSpPr>
           <p:cNvPr id="3" name="Text Placeholder 4"/>
           <p:cNvSpPr>
@@ -2244,12 +2238,13 @@
           <a:lstStyle/>
           <a:p>
             <a:r>
+              <a:rPr/>
               <a:t>Differential FDR&lt;0.25</a:t>
             </a:r>
           </a:p>
         </p:txBody>
       </p:sp>
-      <p:sp>
+      <p:sp xmlns:a="http://schemas.openxmlformats.org/drawingml/2006/main" xmlns:r="http://schemas.openxmlformats.org/officeDocument/2006/relationships" xmlns:p="http://schemas.openxmlformats.org/presentationml/2006/main">
         <p:nvSpPr>
           <p:cNvPr id="4" name="Text Placeholder 2"/>
           <p:cNvSpPr>
@@ -2270,14 +2265,15 @@
           <a:lstStyle/>
           <a:p>
             <a:r>
+              <a:rPr/>
               <a:t>Complete Set FDR=1</a:t>
             </a:r>
           </a:p>
         </p:txBody>
       </p:sp>
-      <p:pic>
+      <p:pic xmlns:a="http://schemas.openxmlformats.org/drawingml/2006/main" xmlns:r="http://schemas.openxmlformats.org/officeDocument/2006/relationships" xmlns:p="http://schemas.openxmlformats.org/presentationml/2006/main">
         <p:nvPicPr>
-          <p:cNvPr id="5" name="Content Placeholder 4"/>
+          <p:cNvPr id="5" name="" descr=""/>
           <p:cNvPicPr>
             <a:picLocks noGrp="1"/>
           </p:cNvPicPr>
@@ -2286,7 +2282,7 @@
           </p:nvPr>
         </p:nvPicPr>
         <p:blipFill>
-          <a:blip r:embed="rId2" cstate="print"/>
+          <a:blip cstate="print" r:embed="rId2"/>
           <a:stretch>
             <a:fillRect/>
           </a:stretch>
@@ -2301,9 +2297,9 @@
           </a:prstGeom>
         </p:spPr>
       </p:pic>
-      <p:pic>
+      <p:pic xmlns:a="http://schemas.openxmlformats.org/drawingml/2006/main" xmlns:r="http://schemas.openxmlformats.org/officeDocument/2006/relationships" xmlns:p="http://schemas.openxmlformats.org/presentationml/2006/main">
         <p:nvPicPr>
-          <p:cNvPr id="6" name="Content Placeholder 5"/>
+          <p:cNvPr id="6" name="" descr=""/>
           <p:cNvPicPr>
             <a:picLocks noGrp="1"/>
           </p:cNvPicPr>
@@ -2312,7 +2308,7 @@
           </p:nvPr>
         </p:nvPicPr>
         <p:blipFill>
-          <a:blip r:embed="rId3" cstate="print"/>
+          <a:blip cstate="print" r:embed="rId3"/>
           <a:stretch>
             <a:fillRect/>
           </a:stretch>
@@ -2352,7 +2348,7 @@
           <a:chExt cx="0" cy="0"/>
         </a:xfrm>
       </p:grpSpPr>
-      <p:sp>
+      <p:sp xmlns:a="http://schemas.openxmlformats.org/drawingml/2006/main" xmlns:r="http://schemas.openxmlformats.org/officeDocument/2006/relationships" xmlns:p="http://schemas.openxmlformats.org/presentationml/2006/main">
         <p:nvSpPr>
           <p:cNvPr id="2" name="Title 1"/>
           <p:cNvSpPr>
@@ -2373,12 +2369,13 @@
           <a:lstStyle/>
           <a:p>
             <a:r>
+              <a:rPr/>
               <a:t>Comparison FemMHFD_over_FemMRD</a:t>
             </a:r>
           </a:p>
         </p:txBody>
       </p:sp>
-      <p:sp>
+      <p:sp xmlns:a="http://schemas.openxmlformats.org/drawingml/2006/main" xmlns:r="http://schemas.openxmlformats.org/officeDocument/2006/relationships" xmlns:p="http://schemas.openxmlformats.org/presentationml/2006/main">
         <p:nvSpPr>
           <p:cNvPr id="3" name="Text Placeholder 4"/>
           <p:cNvSpPr>
@@ -2399,12 +2396,13 @@
           <a:lstStyle/>
           <a:p>
             <a:r>
+              <a:rPr/>
               <a:t>Differential FDR&lt;0.25</a:t>
             </a:r>
           </a:p>
         </p:txBody>
       </p:sp>
-      <p:sp>
+      <p:sp xmlns:a="http://schemas.openxmlformats.org/drawingml/2006/main" xmlns:r="http://schemas.openxmlformats.org/officeDocument/2006/relationships" xmlns:p="http://schemas.openxmlformats.org/presentationml/2006/main">
         <p:nvSpPr>
           <p:cNvPr id="4" name="Text Placeholder 2"/>
           <p:cNvSpPr>
@@ -2425,14 +2423,15 @@
           <a:lstStyle/>
           <a:p>
             <a:r>
+              <a:rPr/>
               <a:t>Complete Set FDR=1</a:t>
             </a:r>
           </a:p>
         </p:txBody>
       </p:sp>
-      <p:pic>
+      <p:pic xmlns:a="http://schemas.openxmlformats.org/drawingml/2006/main" xmlns:r="http://schemas.openxmlformats.org/officeDocument/2006/relationships" xmlns:p="http://schemas.openxmlformats.org/presentationml/2006/main">
         <p:nvPicPr>
-          <p:cNvPr id="5" name="Content Placeholder 4"/>
+          <p:cNvPr id="5" name="" descr=""/>
           <p:cNvPicPr>
             <a:picLocks noGrp="1"/>
           </p:cNvPicPr>
@@ -2441,7 +2440,7 @@
           </p:nvPr>
         </p:nvPicPr>
         <p:blipFill>
-          <a:blip r:embed="rId2" cstate="print"/>
+          <a:blip cstate="print" r:embed="rId2"/>
           <a:stretch>
             <a:fillRect/>
           </a:stretch>
@@ -2481,7 +2480,7 @@
           <a:chExt cx="0" cy="0"/>
         </a:xfrm>
       </p:grpSpPr>
-      <p:sp>
+      <p:sp xmlns:a="http://schemas.openxmlformats.org/drawingml/2006/main" xmlns:r="http://schemas.openxmlformats.org/officeDocument/2006/relationships" xmlns:p="http://schemas.openxmlformats.org/presentationml/2006/main">
         <p:nvSpPr>
           <p:cNvPr id="2" name="Title 1"/>
           <p:cNvSpPr>
@@ -2502,12 +2501,13 @@
           <a:lstStyle/>
           <a:p>
             <a:r>
+              <a:rPr/>
               <a:t>Comparison RDDam_HFDDam_MaleMRD_MaleMHFD_FemMRD_FemMHFD</a:t>
             </a:r>
           </a:p>
         </p:txBody>
       </p:sp>
-      <p:sp>
+      <p:sp xmlns:a="http://schemas.openxmlformats.org/drawingml/2006/main" xmlns:r="http://schemas.openxmlformats.org/officeDocument/2006/relationships" xmlns:p="http://schemas.openxmlformats.org/presentationml/2006/main">
         <p:nvSpPr>
           <p:cNvPr id="3" name="Text Placeholder 4"/>
           <p:cNvSpPr>
@@ -2528,12 +2528,13 @@
           <a:lstStyle/>
           <a:p>
             <a:r>
+              <a:rPr/>
               <a:t>Differential FDR&lt;0.25</a:t>
             </a:r>
           </a:p>
         </p:txBody>
       </p:sp>
-      <p:sp>
+      <p:sp xmlns:a="http://schemas.openxmlformats.org/drawingml/2006/main" xmlns:r="http://schemas.openxmlformats.org/officeDocument/2006/relationships" xmlns:p="http://schemas.openxmlformats.org/presentationml/2006/main">
         <p:nvSpPr>
           <p:cNvPr id="4" name="Text Placeholder 2"/>
           <p:cNvSpPr>
@@ -2554,14 +2555,15 @@
           <a:lstStyle/>
           <a:p>
             <a:r>
+              <a:rPr/>
               <a:t>Complete Set FDR=1</a:t>
             </a:r>
           </a:p>
         </p:txBody>
       </p:sp>
-      <p:pic>
+      <p:pic xmlns:a="http://schemas.openxmlformats.org/drawingml/2006/main" xmlns:r="http://schemas.openxmlformats.org/officeDocument/2006/relationships" xmlns:p="http://schemas.openxmlformats.org/presentationml/2006/main">
         <p:nvPicPr>
-          <p:cNvPr id="5" name="Content Placeholder 4"/>
+          <p:cNvPr id="5" name="" descr=""/>
           <p:cNvPicPr>
             <a:picLocks noGrp="1"/>
           </p:cNvPicPr>
@@ -2570,7 +2572,7 @@
           </p:nvPr>
         </p:nvPicPr>
         <p:blipFill>
-          <a:blip r:embed="rId2" cstate="print"/>
+          <a:blip cstate="print" r:embed="rId2"/>
           <a:stretch>
             <a:fillRect/>
           </a:stretch>
@@ -2585,9 +2587,9 @@
           </a:prstGeom>
         </p:spPr>
       </p:pic>
-      <p:pic>
+      <p:pic xmlns:a="http://schemas.openxmlformats.org/drawingml/2006/main" xmlns:r="http://schemas.openxmlformats.org/officeDocument/2006/relationships" xmlns:p="http://schemas.openxmlformats.org/presentationml/2006/main">
         <p:nvPicPr>
-          <p:cNvPr id="6" name="Content Placeholder 5"/>
+          <p:cNvPr id="6" name="" descr=""/>
           <p:cNvPicPr>
             <a:picLocks noGrp="1"/>
           </p:cNvPicPr>
@@ -2596,7 +2598,7 @@
           </p:nvPr>
         </p:nvPicPr>
         <p:blipFill>
-          <a:blip r:embed="rId3" cstate="print"/>
+          <a:blip cstate="print" r:embed="rId3"/>
           <a:stretch>
             <a:fillRect/>
           </a:stretch>
@@ -2636,7 +2638,7 @@
           <a:chExt cx="0" cy="0"/>
         </a:xfrm>
       </p:grpSpPr>
-      <p:sp>
+      <p:sp xmlns:a="http://schemas.openxmlformats.org/drawingml/2006/main" xmlns:r="http://schemas.openxmlformats.org/officeDocument/2006/relationships" xmlns:p="http://schemas.openxmlformats.org/presentationml/2006/main">
         <p:nvSpPr>
           <p:cNvPr id="2" name="Title 1"/>
           <p:cNvSpPr>
@@ -2657,12 +2659,13 @@
           <a:lstStyle/>
           <a:p>
             <a:r>
+              <a:rPr/>
               <a:t>Project Overview</a:t>
             </a:r>
           </a:p>
         </p:txBody>
       </p:sp>
-      <p:sp>
+      <p:sp xmlns:a="http://schemas.openxmlformats.org/drawingml/2006/main" xmlns:r="http://schemas.openxmlformats.org/officeDocument/2006/relationships" xmlns:p="http://schemas.openxmlformats.org/presentationml/2006/main">
         <p:nvSpPr>
           <p:cNvPr id="3" name="Content Placeholder 2"/>
           <p:cNvSpPr>
@@ -2679,104 +2682,91 @@
           </a:xfrm>
         </p:spPr>
         <p:txBody>
-          <a:bodyPr>
-            <a:normAutofit fontScale="92500" lnSpcReduction="20000"/>
-          </a:bodyPr>
+          <a:bodyPr/>
           <a:lstStyle/>
           <a:p>
-            <a:r>
-              <a:rPr dirty="0"/>
+            <a:pPr/>
+            <a:r>
+              <a:rPr/>
               <a:t>Samples</a:t>
             </a:r>
-            <a:r>
-              <a:rPr lang="en-US" dirty="0"/>
-              <a:t> </a:t>
-            </a:r>
-            <a:endParaRPr dirty="0"/>
           </a:p>
           <a:p>
             <a:pPr lvl="1"/>
             <a:r>
-              <a:rPr dirty="0"/>
+              <a:rPr/>
               <a:t>39 experimental samples</a:t>
             </a:r>
           </a:p>
           <a:p>
             <a:pPr lvl="1"/>
             <a:r>
-              <a:rPr dirty="0"/>
+              <a:rPr/>
               <a:t>3 liver control samples</a:t>
             </a:r>
           </a:p>
           <a:p>
-            <a:r>
-              <a:rPr dirty="0"/>
+            <a:pPr/>
+            <a:r>
+              <a:rPr/>
               <a:t>Total of 23 features from 1 methods</a:t>
             </a:r>
           </a:p>
           <a:p>
             <a:pPr lvl="1"/>
             <a:r>
-              <a:rPr dirty="0" err="1"/>
-              <a:t>AminoAcids</a:t>
-            </a:r>
-            <a:r>
-              <a:rPr dirty="0"/>
-              <a:t> was normalized by Internal Standard L-Tryptophan (ISTD) [CV = 0.05]</a:t>
-            </a:r>
-          </a:p>
-          <a:p>
-            <a:r>
-              <a:rPr dirty="0"/>
+              <a:rPr/>
+              <a:t>AminoAcids was normalized by Internal Standard L-Tryptophan (ISTD) [CV = 0.05]</a:t>
+            </a:r>
+          </a:p>
+          <a:p>
+            <a:pPr/>
+            <a:r>
+              <a:rPr/>
               <a:t>Comparisons performed</a:t>
             </a:r>
           </a:p>
           <a:p>
             <a:pPr lvl="1"/>
             <a:r>
-              <a:rPr dirty="0"/>
+              <a:rPr/>
               <a:t>t-test</a:t>
             </a:r>
           </a:p>
           <a:p>
             <a:pPr lvl="2"/>
             <a:r>
-              <a:rPr dirty="0" err="1"/>
+              <a:rPr/>
               <a:t>HFDDam_over_RDDam</a:t>
             </a:r>
-            <a:endParaRPr dirty="0"/>
           </a:p>
           <a:p>
             <a:pPr lvl="2"/>
             <a:r>
-              <a:rPr dirty="0" err="1"/>
+              <a:rPr/>
               <a:t>MaleMHFD_over_MaleMRD</a:t>
             </a:r>
-            <a:endParaRPr dirty="0"/>
           </a:p>
           <a:p>
             <a:pPr lvl="2"/>
             <a:r>
-              <a:rPr dirty="0" err="1"/>
+              <a:rPr/>
               <a:t>FemMHFD_over_FemMRD</a:t>
             </a:r>
-            <a:endParaRPr dirty="0"/>
           </a:p>
           <a:p>
             <a:pPr lvl="1"/>
             <a:r>
-              <a:rPr dirty="0" err="1"/>
+              <a:rPr/>
               <a:t>anova</a:t>
             </a:r>
-            <a:endParaRPr dirty="0"/>
           </a:p>
           <a:p>
             <a:pPr lvl="2"/>
             <a:r>
-              <a:rPr dirty="0" err="1"/>
+              <a:rPr/>
               <a:t>RDDam_HFDDam_MaleMRD_MaleMHFD_FemMRD_FemMHFD</a:t>
             </a:r>
-            <a:endParaRPr dirty="0"/>
           </a:p>
         </p:txBody>
       </p:sp>
@@ -2805,7 +2795,7 @@
           <a:chExt cx="0" cy="0"/>
         </a:xfrm>
       </p:grpSpPr>
-      <p:sp>
+      <p:sp xmlns:a="http://schemas.openxmlformats.org/drawingml/2006/main" xmlns:r="http://schemas.openxmlformats.org/officeDocument/2006/relationships" xmlns:p="http://schemas.openxmlformats.org/presentationml/2006/main">
         <p:nvSpPr>
           <p:cNvPr id="2" name="Title 1"/>
           <p:cNvSpPr>
@@ -2826,14 +2816,15 @@
           <a:lstStyle/>
           <a:p>
             <a:r>
+              <a:rPr/>
               <a:t>QA plots: all_samples</a:t>
             </a:r>
           </a:p>
         </p:txBody>
       </p:sp>
-      <p:pic>
+      <p:pic xmlns:a="http://schemas.openxmlformats.org/drawingml/2006/main" xmlns:r="http://schemas.openxmlformats.org/officeDocument/2006/relationships" xmlns:p="http://schemas.openxmlformats.org/presentationml/2006/main">
         <p:nvPicPr>
-          <p:cNvPr id="3" name="Content Placeholder 2"/>
+          <p:cNvPr id="3" name="" descr=""/>
           <p:cNvPicPr>
             <a:picLocks noGrp="1"/>
           </p:cNvPicPr>
@@ -2842,7 +2833,7 @@
           </p:nvPr>
         </p:nvPicPr>
         <p:blipFill>
-          <a:blip r:embed="rId2" cstate="print"/>
+          <a:blip cstate="print" r:embed="rId2"/>
           <a:stretch>
             <a:fillRect/>
           </a:stretch>
@@ -2882,7 +2873,7 @@
           <a:chExt cx="0" cy="0"/>
         </a:xfrm>
       </p:grpSpPr>
-      <p:sp>
+      <p:sp xmlns:a="http://schemas.openxmlformats.org/drawingml/2006/main" xmlns:r="http://schemas.openxmlformats.org/officeDocument/2006/relationships" xmlns:p="http://schemas.openxmlformats.org/presentationml/2006/main">
         <p:nvSpPr>
           <p:cNvPr id="2" name="Title 1"/>
           <p:cNvSpPr>
@@ -2903,14 +2894,15 @@
           <a:lstStyle/>
           <a:p>
             <a:r>
+              <a:rPr/>
               <a:t>QA plots: AminoAcids</a:t>
             </a:r>
           </a:p>
         </p:txBody>
       </p:sp>
-      <p:pic>
+      <p:pic xmlns:a="http://schemas.openxmlformats.org/drawingml/2006/main" xmlns:r="http://schemas.openxmlformats.org/officeDocument/2006/relationships" xmlns:p="http://schemas.openxmlformats.org/presentationml/2006/main">
         <p:nvPicPr>
-          <p:cNvPr id="3" name="Content Placeholder 2"/>
+          <p:cNvPr id="3" name="" descr=""/>
           <p:cNvPicPr>
             <a:picLocks noGrp="1"/>
           </p:cNvPicPr>
@@ -2919,7 +2911,7 @@
           </p:nvPr>
         </p:nvPicPr>
         <p:blipFill>
-          <a:blip r:embed="rId2" cstate="print"/>
+          <a:blip cstate="print" r:embed="rId2"/>
           <a:stretch>
             <a:fillRect/>
           </a:stretch>
@@ -2959,7 +2951,7 @@
           <a:chExt cx="0" cy="0"/>
         </a:xfrm>
       </p:grpSpPr>
-      <p:sp>
+      <p:sp xmlns:a="http://schemas.openxmlformats.org/drawingml/2006/main" xmlns:r="http://schemas.openxmlformats.org/officeDocument/2006/relationships" xmlns:p="http://schemas.openxmlformats.org/presentationml/2006/main">
         <p:nvSpPr>
           <p:cNvPr id="2" name="Title 1"/>
           <p:cNvSpPr>
@@ -2980,14 +2972,15 @@
           <a:lstStyle/>
           <a:p>
             <a:r>
+              <a:rPr/>
               <a:t>Liver Control: AminoAcids</a:t>
             </a:r>
           </a:p>
         </p:txBody>
       </p:sp>
-      <p:pic>
+      <p:pic xmlns:a="http://schemas.openxmlformats.org/drawingml/2006/main" xmlns:r="http://schemas.openxmlformats.org/officeDocument/2006/relationships" xmlns:p="http://schemas.openxmlformats.org/presentationml/2006/main">
         <p:nvPicPr>
-          <p:cNvPr id="3" name="Content Placeholder 2"/>
+          <p:cNvPr id="3" name="" descr=""/>
           <p:cNvPicPr>
             <a:picLocks noGrp="1"/>
           </p:cNvPicPr>
@@ -2996,7 +2989,7 @@
           </p:nvPr>
         </p:nvPicPr>
         <p:blipFill>
-          <a:blip r:embed="rId2" cstate="print"/>
+          <a:blip cstate="print" r:embed="rId2"/>
           <a:stretch>
             <a:fillRect/>
           </a:stretch>
@@ -3036,7 +3029,7 @@
           <a:chExt cx="0" cy="0"/>
         </a:xfrm>
       </p:grpSpPr>
-      <p:sp>
+      <p:sp xmlns:a="http://schemas.openxmlformats.org/drawingml/2006/main" xmlns:r="http://schemas.openxmlformats.org/officeDocument/2006/relationships" xmlns:p="http://schemas.openxmlformats.org/presentationml/2006/main">
         <p:nvSpPr>
           <p:cNvPr id="2" name="Title 1"/>
           <p:cNvSpPr>
@@ -3057,14 +3050,15 @@
           <a:lstStyle/>
           <a:p>
             <a:r>
+              <a:rPr/>
               <a:t>Internal Standards Distribution: AminoAcids</a:t>
             </a:r>
           </a:p>
         </p:txBody>
       </p:sp>
-      <p:pic>
+      <p:pic xmlns:a="http://schemas.openxmlformats.org/drawingml/2006/main" xmlns:r="http://schemas.openxmlformats.org/officeDocument/2006/relationships" xmlns:p="http://schemas.openxmlformats.org/presentationml/2006/main">
         <p:nvPicPr>
-          <p:cNvPr id="3" name="Content Placeholder 2"/>
+          <p:cNvPr id="3" name="" descr=""/>
           <p:cNvPicPr>
             <a:picLocks noGrp="1"/>
           </p:cNvPicPr>
@@ -3073,7 +3067,7 @@
           </p:nvPr>
         </p:nvPicPr>
         <p:blipFill>
-          <a:blip r:embed="rId2" cstate="print"/>
+          <a:blip cstate="print" r:embed="rId2"/>
           <a:stretch>
             <a:fillRect/>
           </a:stretch>
@@ -3113,7 +3107,7 @@
           <a:chExt cx="0" cy="0"/>
         </a:xfrm>
       </p:grpSpPr>
-      <p:sp>
+      <p:sp xmlns:a="http://schemas.openxmlformats.org/drawingml/2006/main" xmlns:r="http://schemas.openxmlformats.org/officeDocument/2006/relationships" xmlns:p="http://schemas.openxmlformats.org/presentationml/2006/main">
         <p:nvSpPr>
           <p:cNvPr id="2" name="Title 1"/>
           <p:cNvSpPr>
@@ -3134,12 +3128,13 @@
           <a:lstStyle/>
           <a:p>
             <a:r>
+              <a:rPr/>
               <a:t>Comparison HFDDam_over_RDDam</a:t>
             </a:r>
           </a:p>
         </p:txBody>
       </p:sp>
-      <p:sp>
+      <p:sp xmlns:a="http://schemas.openxmlformats.org/drawingml/2006/main" xmlns:r="http://schemas.openxmlformats.org/officeDocument/2006/relationships" xmlns:p="http://schemas.openxmlformats.org/presentationml/2006/main">
         <p:nvSpPr>
           <p:cNvPr id="3" name="Text Placeholder 4"/>
           <p:cNvSpPr>
@@ -3160,12 +3155,13 @@
           <a:lstStyle/>
           <a:p>
             <a:r>
+              <a:rPr/>
               <a:t>Normalized PCA</a:t>
             </a:r>
           </a:p>
         </p:txBody>
       </p:sp>
-      <p:sp>
+      <p:sp xmlns:a="http://schemas.openxmlformats.org/drawingml/2006/main" xmlns:r="http://schemas.openxmlformats.org/officeDocument/2006/relationships" xmlns:p="http://schemas.openxmlformats.org/presentationml/2006/main">
         <p:nvSpPr>
           <p:cNvPr id="4" name="Text Placeholder 2"/>
           <p:cNvSpPr>
@@ -3186,14 +3182,15 @@
           <a:lstStyle/>
           <a:p>
             <a:r>
+              <a:rPr/>
               <a:t>Raw PCA</a:t>
             </a:r>
           </a:p>
         </p:txBody>
       </p:sp>
-      <p:pic>
+      <p:pic xmlns:a="http://schemas.openxmlformats.org/drawingml/2006/main" xmlns:r="http://schemas.openxmlformats.org/officeDocument/2006/relationships" xmlns:p="http://schemas.openxmlformats.org/presentationml/2006/main">
         <p:nvPicPr>
-          <p:cNvPr id="5" name="Content Placeholder 4"/>
+          <p:cNvPr id="5" name="" descr=""/>
           <p:cNvPicPr>
             <a:picLocks noGrp="1"/>
           </p:cNvPicPr>
@@ -3202,7 +3199,7 @@
           </p:nvPr>
         </p:nvPicPr>
         <p:blipFill>
-          <a:blip r:embed="rId2" cstate="print"/>
+          <a:blip cstate="print" r:embed="rId2"/>
           <a:stretch>
             <a:fillRect/>
           </a:stretch>
@@ -3217,9 +3214,9 @@
           </a:prstGeom>
         </p:spPr>
       </p:pic>
-      <p:pic>
+      <p:pic xmlns:a="http://schemas.openxmlformats.org/drawingml/2006/main" xmlns:r="http://schemas.openxmlformats.org/officeDocument/2006/relationships" xmlns:p="http://schemas.openxmlformats.org/presentationml/2006/main">
         <p:nvPicPr>
-          <p:cNvPr id="6" name="Content Placeholder 5"/>
+          <p:cNvPr id="6" name="" descr=""/>
           <p:cNvPicPr>
             <a:picLocks noGrp="1"/>
           </p:cNvPicPr>
@@ -3228,7 +3225,7 @@
           </p:nvPr>
         </p:nvPicPr>
         <p:blipFill>
-          <a:blip r:embed="rId3" cstate="print"/>
+          <a:blip cstate="print" r:embed="rId3"/>
           <a:stretch>
             <a:fillRect/>
           </a:stretch>
@@ -3268,7 +3265,7 @@
           <a:chExt cx="0" cy="0"/>
         </a:xfrm>
       </p:grpSpPr>
-      <p:sp>
+      <p:sp xmlns:a="http://schemas.openxmlformats.org/drawingml/2006/main" xmlns:r="http://schemas.openxmlformats.org/officeDocument/2006/relationships" xmlns:p="http://schemas.openxmlformats.org/presentationml/2006/main">
         <p:nvSpPr>
           <p:cNvPr id="2" name="Title 1"/>
           <p:cNvSpPr>
@@ -3289,12 +3286,13 @@
           <a:lstStyle/>
           <a:p>
             <a:r>
+              <a:rPr/>
               <a:t>Comparison MaleMHFD_over_MaleMRD</a:t>
             </a:r>
           </a:p>
         </p:txBody>
       </p:sp>
-      <p:sp>
+      <p:sp xmlns:a="http://schemas.openxmlformats.org/drawingml/2006/main" xmlns:r="http://schemas.openxmlformats.org/officeDocument/2006/relationships" xmlns:p="http://schemas.openxmlformats.org/presentationml/2006/main">
         <p:nvSpPr>
           <p:cNvPr id="3" name="Text Placeholder 4"/>
           <p:cNvSpPr>
@@ -3315,12 +3313,13 @@
           <a:lstStyle/>
           <a:p>
             <a:r>
+              <a:rPr/>
               <a:t>Normalized PCA</a:t>
             </a:r>
           </a:p>
         </p:txBody>
       </p:sp>
-      <p:sp>
+      <p:sp xmlns:a="http://schemas.openxmlformats.org/drawingml/2006/main" xmlns:r="http://schemas.openxmlformats.org/officeDocument/2006/relationships" xmlns:p="http://schemas.openxmlformats.org/presentationml/2006/main">
         <p:nvSpPr>
           <p:cNvPr id="4" name="Text Placeholder 2"/>
           <p:cNvSpPr>
@@ -3341,14 +3340,15 @@
           <a:lstStyle/>
           <a:p>
             <a:r>
+              <a:rPr/>
               <a:t>Raw PCA</a:t>
             </a:r>
           </a:p>
         </p:txBody>
       </p:sp>
-      <p:pic>
+      <p:pic xmlns:a="http://schemas.openxmlformats.org/drawingml/2006/main" xmlns:r="http://schemas.openxmlformats.org/officeDocument/2006/relationships" xmlns:p="http://schemas.openxmlformats.org/presentationml/2006/main">
         <p:nvPicPr>
-          <p:cNvPr id="5" name="Content Placeholder 4"/>
+          <p:cNvPr id="5" name="" descr=""/>
           <p:cNvPicPr>
             <a:picLocks noGrp="1"/>
           </p:cNvPicPr>
@@ -3357,7 +3357,7 @@
           </p:nvPr>
         </p:nvPicPr>
         <p:blipFill>
-          <a:blip r:embed="rId2" cstate="print"/>
+          <a:blip cstate="print" r:embed="rId2"/>
           <a:stretch>
             <a:fillRect/>
           </a:stretch>
@@ -3372,9 +3372,9 @@
           </a:prstGeom>
         </p:spPr>
       </p:pic>
-      <p:pic>
+      <p:pic xmlns:a="http://schemas.openxmlformats.org/drawingml/2006/main" xmlns:r="http://schemas.openxmlformats.org/officeDocument/2006/relationships" xmlns:p="http://schemas.openxmlformats.org/presentationml/2006/main">
         <p:nvPicPr>
-          <p:cNvPr id="6" name="Content Placeholder 5"/>
+          <p:cNvPr id="6" name="" descr=""/>
           <p:cNvPicPr>
             <a:picLocks noGrp="1"/>
           </p:cNvPicPr>
@@ -3383,7 +3383,7 @@
           </p:nvPr>
         </p:nvPicPr>
         <p:blipFill>
-          <a:blip r:embed="rId3" cstate="print"/>
+          <a:blip cstate="print" r:embed="rId3"/>
           <a:stretch>
             <a:fillRect/>
           </a:stretch>
@@ -3423,7 +3423,7 @@
           <a:chExt cx="0" cy="0"/>
         </a:xfrm>
       </p:grpSpPr>
-      <p:sp>
+      <p:sp xmlns:a="http://schemas.openxmlformats.org/drawingml/2006/main" xmlns:r="http://schemas.openxmlformats.org/officeDocument/2006/relationships" xmlns:p="http://schemas.openxmlformats.org/presentationml/2006/main">
         <p:nvSpPr>
           <p:cNvPr id="2" name="Title 1"/>
           <p:cNvSpPr>
@@ -3444,12 +3444,13 @@
           <a:lstStyle/>
           <a:p>
             <a:r>
+              <a:rPr/>
               <a:t>Comparison FemMHFD_over_FemMRD</a:t>
             </a:r>
           </a:p>
         </p:txBody>
       </p:sp>
-      <p:sp>
+      <p:sp xmlns:a="http://schemas.openxmlformats.org/drawingml/2006/main" xmlns:r="http://schemas.openxmlformats.org/officeDocument/2006/relationships" xmlns:p="http://schemas.openxmlformats.org/presentationml/2006/main">
         <p:nvSpPr>
           <p:cNvPr id="3" name="Text Placeholder 4"/>
           <p:cNvSpPr>
@@ -3470,12 +3471,13 @@
           <a:lstStyle/>
           <a:p>
             <a:r>
+              <a:rPr/>
               <a:t>Normalized PCA</a:t>
             </a:r>
           </a:p>
         </p:txBody>
       </p:sp>
-      <p:sp>
+      <p:sp xmlns:a="http://schemas.openxmlformats.org/drawingml/2006/main" xmlns:r="http://schemas.openxmlformats.org/officeDocument/2006/relationships" xmlns:p="http://schemas.openxmlformats.org/presentationml/2006/main">
         <p:nvSpPr>
           <p:cNvPr id="4" name="Text Placeholder 2"/>
           <p:cNvSpPr>
@@ -3496,14 +3498,15 @@
           <a:lstStyle/>
           <a:p>
             <a:r>
+              <a:rPr/>
               <a:t>Raw PCA</a:t>
             </a:r>
           </a:p>
         </p:txBody>
       </p:sp>
-      <p:pic>
+      <p:pic xmlns:a="http://schemas.openxmlformats.org/drawingml/2006/main" xmlns:r="http://schemas.openxmlformats.org/officeDocument/2006/relationships" xmlns:p="http://schemas.openxmlformats.org/presentationml/2006/main">
         <p:nvPicPr>
-          <p:cNvPr id="5" name="Content Placeholder 4"/>
+          <p:cNvPr id="5" name="" descr=""/>
           <p:cNvPicPr>
             <a:picLocks noGrp="1"/>
           </p:cNvPicPr>
@@ -3512,7 +3515,7 @@
           </p:nvPr>
         </p:nvPicPr>
         <p:blipFill>
-          <a:blip r:embed="rId2" cstate="print"/>
+          <a:blip cstate="print" r:embed="rId2"/>
           <a:stretch>
             <a:fillRect/>
           </a:stretch>
@@ -3527,9 +3530,9 @@
           </a:prstGeom>
         </p:spPr>
       </p:pic>
-      <p:pic>
+      <p:pic xmlns:a="http://schemas.openxmlformats.org/drawingml/2006/main" xmlns:r="http://schemas.openxmlformats.org/officeDocument/2006/relationships" xmlns:p="http://schemas.openxmlformats.org/presentationml/2006/main">
         <p:nvPicPr>
-          <p:cNvPr id="6" name="Content Placeholder 5"/>
+          <p:cNvPr id="6" name="" descr=""/>
           <p:cNvPicPr>
             <a:picLocks noGrp="1"/>
           </p:cNvPicPr>
@@ -3538,7 +3541,7 @@
           </p:nvPr>
         </p:nvPicPr>
         <p:blipFill>
-          <a:blip r:embed="rId3" cstate="print"/>
+          <a:blip cstate="print" r:embed="rId3"/>
           <a:stretch>
             <a:fillRect/>
           </a:stretch>

</xml_diff>

<commit_message>
added heatmap color scale option
now user can specify the color scale they want used for heatmaps using the `heatmap_color_scale` parameter. default is `heatmap_color_scale = c("blue", "black", "yellow")`.
Also updated the results for example3-iqr with a blue, white and red color scale to show an example of setting `heatmap_color_scale` manually.
closes #8
</commit_message>
<xml_diff>
--- a/example1-metabolomics/results-A/report.pptx
+++ b/example1-metabolomics/results-A/report.pptx
@@ -5,26 +5,26 @@
     <p:sldMasterId id="2147483660" r:id="rId1"/>
   </p:sldMasterIdLst>
   <p:notesMasterIdLst>
-    <p:notesMasterId r:id="rId2"/>
+    <p:notesMasterId r:id="rId16"/>
   </p:notesMasterIdLst>
   <p:handoutMasterIdLst>
-    <p:handoutMasterId r:id="rId3"/>
+    <p:handoutMasterId r:id="rId17"/>
   </p:handoutMasterIdLst>
-  <p:sldIdLst xmlns:a="http://schemas.openxmlformats.org/drawingml/2006/main" xmlns:r="http://schemas.openxmlformats.org/officeDocument/2006/relationships" xmlns:p="http://schemas.openxmlformats.org/presentationml/2006/main">
-    <p:sldId id="256" r:id="rId8"/>
-    <p:sldId id="257" r:id="rId9"/>
-    <p:sldId id="258" r:id="rId10"/>
-    <p:sldId id="259" r:id="rId11"/>
-    <p:sldId id="260" r:id="rId12"/>
-    <p:sldId id="261" r:id="rId13"/>
-    <p:sldId id="262" r:id="rId14"/>
-    <p:sldId id="263" r:id="rId15"/>
-    <p:sldId id="264" r:id="rId16"/>
-    <p:sldId id="265" r:id="rId17"/>
-    <p:sldId id="266" r:id="rId18"/>
-    <p:sldId id="267" r:id="rId19"/>
-    <p:sldId id="268" r:id="rId20"/>
-    <p:sldId id="269" r:id="rId21"/>
+  <p:sldIdLst>
+    <p:sldId id="256" r:id="rId2"/>
+    <p:sldId id="257" r:id="rId3"/>
+    <p:sldId id="258" r:id="rId4"/>
+    <p:sldId id="259" r:id="rId5"/>
+    <p:sldId id="260" r:id="rId6"/>
+    <p:sldId id="261" r:id="rId7"/>
+    <p:sldId id="262" r:id="rId8"/>
+    <p:sldId id="263" r:id="rId9"/>
+    <p:sldId id="264" r:id="rId10"/>
+    <p:sldId id="265" r:id="rId11"/>
+    <p:sldId id="266" r:id="rId12"/>
+    <p:sldId id="267" r:id="rId13"/>
+    <p:sldId id="268" r:id="rId14"/>
+    <p:sldId id="269" r:id="rId15"/>
   </p:sldIdLst>
   <p:sldSz cx="9144000" cy="6858000" type="screen4x3"/>
   <p:notesSz cx="6858000" cy="9144000"/>
@@ -127,7 +127,22 @@
     <p:ext uri="{521415D9-36F7-43E2-AB2F-B90AF26B5E84}">
       <p14:sectionLst xmlns:p14="http://schemas.microsoft.com/office/powerpoint/2010/main">
         <p14:section name="Default Section" id="{23E95266-8A91-634B-9D8A-82E9C2DFC7E6}">
-          <p14:sldIdLst/>
+          <p14:sldIdLst>
+            <p14:sldId id="256"/>
+            <p14:sldId id="257"/>
+            <p14:sldId id="258"/>
+            <p14:sldId id="259"/>
+            <p14:sldId id="260"/>
+            <p14:sldId id="261"/>
+            <p14:sldId id="262"/>
+            <p14:sldId id="263"/>
+            <p14:sldId id="264"/>
+            <p14:sldId id="265"/>
+            <p14:sldId id="266"/>
+            <p14:sldId id="267"/>
+            <p14:sldId id="268"/>
+            <p14:sldId id="269"/>
+          </p14:sldIdLst>
         </p14:section>
       </p14:sectionLst>
     </p:ext>
@@ -231,7 +246,7 @@
           <a:p>
             <a:fld id="{12475388-B706-A848-A46B-DDB877936374}" type="datetimeFigureOut">
               <a:rPr lang="en-US" smtClean="0"/>
-              <a:t>1/29/18</a:t>
+              <a:t>3/29/23</a:t>
             </a:fld>
             <a:endParaRPr lang="en-US"/>
           </a:p>
@@ -397,7 +412,7 @@
           <a:p>
             <a:fld id="{A5587B2F-58BE-554B-B170-DCECE273C696}" type="datetimeFigureOut">
               <a:rPr lang="en-US" smtClean="0"/>
-              <a:t>1/29/18</a:t>
+              <a:t>3/29/23</a:t>
             </a:fld>
             <a:endParaRPr lang="en-US"/>
           </a:p>
@@ -1795,7 +1810,7 @@
           <a:chExt cx="0" cy="0"/>
         </a:xfrm>
       </p:grpSpPr>
-      <p:sp xmlns:a="http://schemas.openxmlformats.org/drawingml/2006/main" xmlns:r="http://schemas.openxmlformats.org/officeDocument/2006/relationships" xmlns:p="http://schemas.openxmlformats.org/presentationml/2006/main">
+      <p:sp>
         <p:nvSpPr>
           <p:cNvPr id="2" name="Title 1"/>
           <p:cNvSpPr>
@@ -1816,13 +1831,12 @@
           <a:lstStyle/>
           <a:p>
             <a:r>
-              <a:rPr/>
               <a:t>Project Report</a:t>
             </a:r>
           </a:p>
         </p:txBody>
       </p:sp>
-      <p:sp xmlns:a="http://schemas.openxmlformats.org/drawingml/2006/main" xmlns:r="http://schemas.openxmlformats.org/officeDocument/2006/relationships" xmlns:p="http://schemas.openxmlformats.org/presentationml/2006/main">
+      <p:sp>
         <p:nvSpPr>
           <p:cNvPr id="3" name="Subtitle 2"/>
           <p:cNvSpPr>
@@ -1843,7 +1857,6 @@
           <a:lstStyle/>
           <a:p>
             <a:r>
-              <a:rPr/>
               <a:t>Metabolomics Analysis</a:t>
             </a:r>
           </a:p>
@@ -1874,7 +1887,7 @@
           <a:chExt cx="0" cy="0"/>
         </a:xfrm>
       </p:grpSpPr>
-      <p:sp xmlns:a="http://schemas.openxmlformats.org/drawingml/2006/main" xmlns:r="http://schemas.openxmlformats.org/officeDocument/2006/relationships" xmlns:p="http://schemas.openxmlformats.org/presentationml/2006/main">
+      <p:sp>
         <p:nvSpPr>
           <p:cNvPr id="2" name="Title 1"/>
           <p:cNvSpPr>
@@ -1895,13 +1908,12 @@
           <a:lstStyle/>
           <a:p>
             <a:r>
-              <a:rPr/>
               <a:t>Comparison RDDam_HFDDam_MaleMRD_MaleMHFD_FemMRD_FemMHFD</a:t>
             </a:r>
           </a:p>
         </p:txBody>
       </p:sp>
-      <p:sp xmlns:a="http://schemas.openxmlformats.org/drawingml/2006/main" xmlns:r="http://schemas.openxmlformats.org/officeDocument/2006/relationships" xmlns:p="http://schemas.openxmlformats.org/presentationml/2006/main">
+      <p:sp>
         <p:nvSpPr>
           <p:cNvPr id="3" name="Text Placeholder 4"/>
           <p:cNvSpPr>
@@ -1922,13 +1934,12 @@
           <a:lstStyle/>
           <a:p>
             <a:r>
-              <a:rPr/>
               <a:t>Normalized PCA</a:t>
             </a:r>
           </a:p>
         </p:txBody>
       </p:sp>
-      <p:sp xmlns:a="http://schemas.openxmlformats.org/drawingml/2006/main" xmlns:r="http://schemas.openxmlformats.org/officeDocument/2006/relationships" xmlns:p="http://schemas.openxmlformats.org/presentationml/2006/main">
+      <p:sp>
         <p:nvSpPr>
           <p:cNvPr id="4" name="Text Placeholder 2"/>
           <p:cNvSpPr>
@@ -1949,15 +1960,14 @@
           <a:lstStyle/>
           <a:p>
             <a:r>
-              <a:rPr/>
               <a:t>Raw PCA</a:t>
             </a:r>
           </a:p>
         </p:txBody>
       </p:sp>
-      <p:pic xmlns:a="http://schemas.openxmlformats.org/drawingml/2006/main" xmlns:r="http://schemas.openxmlformats.org/officeDocument/2006/relationships" xmlns:p="http://schemas.openxmlformats.org/presentationml/2006/main">
+      <p:pic>
         <p:nvPicPr>
-          <p:cNvPr id="5" name="" descr=""/>
+          <p:cNvPr id="5" name="Content Placeholder 4"/>
           <p:cNvPicPr>
             <a:picLocks noGrp="1"/>
           </p:cNvPicPr>
@@ -1966,7 +1976,7 @@
           </p:nvPr>
         </p:nvPicPr>
         <p:blipFill>
-          <a:blip cstate="print" r:embed="rId2"/>
+          <a:blip r:embed="rId2" cstate="print"/>
           <a:stretch>
             <a:fillRect/>
           </a:stretch>
@@ -1981,9 +1991,9 @@
           </a:prstGeom>
         </p:spPr>
       </p:pic>
-      <p:pic xmlns:a="http://schemas.openxmlformats.org/drawingml/2006/main" xmlns:r="http://schemas.openxmlformats.org/officeDocument/2006/relationships" xmlns:p="http://schemas.openxmlformats.org/presentationml/2006/main">
+      <p:pic>
         <p:nvPicPr>
-          <p:cNvPr id="6" name="" descr=""/>
+          <p:cNvPr id="6" name="Content Placeholder 5"/>
           <p:cNvPicPr>
             <a:picLocks noGrp="1"/>
           </p:cNvPicPr>
@@ -1992,7 +2002,7 @@
           </p:nvPr>
         </p:nvPicPr>
         <p:blipFill>
-          <a:blip cstate="print" r:embed="rId3"/>
+          <a:blip r:embed="rId3" cstate="print"/>
           <a:stretch>
             <a:fillRect/>
           </a:stretch>
@@ -2032,7 +2042,7 @@
           <a:chExt cx="0" cy="0"/>
         </a:xfrm>
       </p:grpSpPr>
-      <p:sp xmlns:a="http://schemas.openxmlformats.org/drawingml/2006/main" xmlns:r="http://schemas.openxmlformats.org/officeDocument/2006/relationships" xmlns:p="http://schemas.openxmlformats.org/presentationml/2006/main">
+      <p:sp>
         <p:nvSpPr>
           <p:cNvPr id="2" name="Title 1"/>
           <p:cNvSpPr>
@@ -2053,13 +2063,12 @@
           <a:lstStyle/>
           <a:p>
             <a:r>
-              <a:rPr/>
               <a:t>Comparison HFDDam_over_RDDam</a:t>
             </a:r>
           </a:p>
         </p:txBody>
       </p:sp>
-      <p:sp xmlns:a="http://schemas.openxmlformats.org/drawingml/2006/main" xmlns:r="http://schemas.openxmlformats.org/officeDocument/2006/relationships" xmlns:p="http://schemas.openxmlformats.org/presentationml/2006/main">
+      <p:sp>
         <p:nvSpPr>
           <p:cNvPr id="3" name="Text Placeholder 4"/>
           <p:cNvSpPr>
@@ -2080,13 +2089,12 @@
           <a:lstStyle/>
           <a:p>
             <a:r>
-              <a:rPr/>
               <a:t>Differential FDR&lt;0.25</a:t>
             </a:r>
           </a:p>
         </p:txBody>
       </p:sp>
-      <p:sp xmlns:a="http://schemas.openxmlformats.org/drawingml/2006/main" xmlns:r="http://schemas.openxmlformats.org/officeDocument/2006/relationships" xmlns:p="http://schemas.openxmlformats.org/presentationml/2006/main">
+      <p:sp>
         <p:nvSpPr>
           <p:cNvPr id="4" name="Text Placeholder 2"/>
           <p:cNvSpPr>
@@ -2107,15 +2115,14 @@
           <a:lstStyle/>
           <a:p>
             <a:r>
-              <a:rPr/>
               <a:t>Complete Set FDR=1</a:t>
             </a:r>
           </a:p>
         </p:txBody>
       </p:sp>
-      <p:pic xmlns:a="http://schemas.openxmlformats.org/drawingml/2006/main" xmlns:r="http://schemas.openxmlformats.org/officeDocument/2006/relationships" xmlns:p="http://schemas.openxmlformats.org/presentationml/2006/main">
+      <p:pic>
         <p:nvPicPr>
-          <p:cNvPr id="5" name="" descr=""/>
+          <p:cNvPr id="5" name="Content Placeholder 4"/>
           <p:cNvPicPr>
             <a:picLocks noGrp="1"/>
           </p:cNvPicPr>
@@ -2124,7 +2131,7 @@
           </p:nvPr>
         </p:nvPicPr>
         <p:blipFill>
-          <a:blip cstate="print" r:embed="rId2"/>
+          <a:blip r:embed="rId2" cstate="print"/>
           <a:stretch>
             <a:fillRect/>
           </a:stretch>
@@ -2139,9 +2146,9 @@
           </a:prstGeom>
         </p:spPr>
       </p:pic>
-      <p:pic xmlns:a="http://schemas.openxmlformats.org/drawingml/2006/main" xmlns:r="http://schemas.openxmlformats.org/officeDocument/2006/relationships" xmlns:p="http://schemas.openxmlformats.org/presentationml/2006/main">
+      <p:pic>
         <p:nvPicPr>
-          <p:cNvPr id="6" name="" descr=""/>
+          <p:cNvPr id="6" name="Content Placeholder 5"/>
           <p:cNvPicPr>
             <a:picLocks noGrp="1"/>
           </p:cNvPicPr>
@@ -2150,7 +2157,7 @@
           </p:nvPr>
         </p:nvPicPr>
         <p:blipFill>
-          <a:blip cstate="print" r:embed="rId3"/>
+          <a:blip r:embed="rId3" cstate="print"/>
           <a:stretch>
             <a:fillRect/>
           </a:stretch>
@@ -2190,7 +2197,7 @@
           <a:chExt cx="0" cy="0"/>
         </a:xfrm>
       </p:grpSpPr>
-      <p:sp xmlns:a="http://schemas.openxmlformats.org/drawingml/2006/main" xmlns:r="http://schemas.openxmlformats.org/officeDocument/2006/relationships" xmlns:p="http://schemas.openxmlformats.org/presentationml/2006/main">
+      <p:sp>
         <p:nvSpPr>
           <p:cNvPr id="2" name="Title 1"/>
           <p:cNvSpPr>
@@ -2211,13 +2218,12 @@
           <a:lstStyle/>
           <a:p>
             <a:r>
-              <a:rPr/>
               <a:t>Comparison MaleMHFD_over_MaleMRD</a:t>
             </a:r>
           </a:p>
         </p:txBody>
       </p:sp>
-      <p:sp xmlns:a="http://schemas.openxmlformats.org/drawingml/2006/main" xmlns:r="http://schemas.openxmlformats.org/officeDocument/2006/relationships" xmlns:p="http://schemas.openxmlformats.org/presentationml/2006/main">
+      <p:sp>
         <p:nvSpPr>
           <p:cNvPr id="3" name="Text Placeholder 4"/>
           <p:cNvSpPr>
@@ -2238,13 +2244,12 @@
           <a:lstStyle/>
           <a:p>
             <a:r>
-              <a:rPr/>
               <a:t>Differential FDR&lt;0.25</a:t>
             </a:r>
           </a:p>
         </p:txBody>
       </p:sp>
-      <p:sp xmlns:a="http://schemas.openxmlformats.org/drawingml/2006/main" xmlns:r="http://schemas.openxmlformats.org/officeDocument/2006/relationships" xmlns:p="http://schemas.openxmlformats.org/presentationml/2006/main">
+      <p:sp>
         <p:nvSpPr>
           <p:cNvPr id="4" name="Text Placeholder 2"/>
           <p:cNvSpPr>
@@ -2265,15 +2270,14 @@
           <a:lstStyle/>
           <a:p>
             <a:r>
-              <a:rPr/>
               <a:t>Complete Set FDR=1</a:t>
             </a:r>
           </a:p>
         </p:txBody>
       </p:sp>
-      <p:pic xmlns:a="http://schemas.openxmlformats.org/drawingml/2006/main" xmlns:r="http://schemas.openxmlformats.org/officeDocument/2006/relationships" xmlns:p="http://schemas.openxmlformats.org/presentationml/2006/main">
+      <p:pic>
         <p:nvPicPr>
-          <p:cNvPr id="5" name="" descr=""/>
+          <p:cNvPr id="5" name="Content Placeholder 4"/>
           <p:cNvPicPr>
             <a:picLocks noGrp="1"/>
           </p:cNvPicPr>
@@ -2282,7 +2286,7 @@
           </p:nvPr>
         </p:nvPicPr>
         <p:blipFill>
-          <a:blip cstate="print" r:embed="rId2"/>
+          <a:blip r:embed="rId2" cstate="print"/>
           <a:stretch>
             <a:fillRect/>
           </a:stretch>
@@ -2297,9 +2301,9 @@
           </a:prstGeom>
         </p:spPr>
       </p:pic>
-      <p:pic xmlns:a="http://schemas.openxmlformats.org/drawingml/2006/main" xmlns:r="http://schemas.openxmlformats.org/officeDocument/2006/relationships" xmlns:p="http://schemas.openxmlformats.org/presentationml/2006/main">
+      <p:pic>
         <p:nvPicPr>
-          <p:cNvPr id="6" name="" descr=""/>
+          <p:cNvPr id="6" name="Content Placeholder 5"/>
           <p:cNvPicPr>
             <a:picLocks noGrp="1"/>
           </p:cNvPicPr>
@@ -2308,7 +2312,7 @@
           </p:nvPr>
         </p:nvPicPr>
         <p:blipFill>
-          <a:blip cstate="print" r:embed="rId3"/>
+          <a:blip r:embed="rId3" cstate="print"/>
           <a:stretch>
             <a:fillRect/>
           </a:stretch>
@@ -2348,7 +2352,7 @@
           <a:chExt cx="0" cy="0"/>
         </a:xfrm>
       </p:grpSpPr>
-      <p:sp xmlns:a="http://schemas.openxmlformats.org/drawingml/2006/main" xmlns:r="http://schemas.openxmlformats.org/officeDocument/2006/relationships" xmlns:p="http://schemas.openxmlformats.org/presentationml/2006/main">
+      <p:sp>
         <p:nvSpPr>
           <p:cNvPr id="2" name="Title 1"/>
           <p:cNvSpPr>
@@ -2369,13 +2373,12 @@
           <a:lstStyle/>
           <a:p>
             <a:r>
-              <a:rPr/>
               <a:t>Comparison FemMHFD_over_FemMRD</a:t>
             </a:r>
           </a:p>
         </p:txBody>
       </p:sp>
-      <p:sp xmlns:a="http://schemas.openxmlformats.org/drawingml/2006/main" xmlns:r="http://schemas.openxmlformats.org/officeDocument/2006/relationships" xmlns:p="http://schemas.openxmlformats.org/presentationml/2006/main">
+      <p:sp>
         <p:nvSpPr>
           <p:cNvPr id="3" name="Text Placeholder 4"/>
           <p:cNvSpPr>
@@ -2396,13 +2399,12 @@
           <a:lstStyle/>
           <a:p>
             <a:r>
-              <a:rPr/>
               <a:t>Differential FDR&lt;0.25</a:t>
             </a:r>
           </a:p>
         </p:txBody>
       </p:sp>
-      <p:sp xmlns:a="http://schemas.openxmlformats.org/drawingml/2006/main" xmlns:r="http://schemas.openxmlformats.org/officeDocument/2006/relationships" xmlns:p="http://schemas.openxmlformats.org/presentationml/2006/main">
+      <p:sp>
         <p:nvSpPr>
           <p:cNvPr id="4" name="Text Placeholder 2"/>
           <p:cNvSpPr>
@@ -2423,15 +2425,14 @@
           <a:lstStyle/>
           <a:p>
             <a:r>
-              <a:rPr/>
               <a:t>Complete Set FDR=1</a:t>
             </a:r>
           </a:p>
         </p:txBody>
       </p:sp>
-      <p:pic xmlns:a="http://schemas.openxmlformats.org/drawingml/2006/main" xmlns:r="http://schemas.openxmlformats.org/officeDocument/2006/relationships" xmlns:p="http://schemas.openxmlformats.org/presentationml/2006/main">
+      <p:pic>
         <p:nvPicPr>
-          <p:cNvPr id="5" name="" descr=""/>
+          <p:cNvPr id="5" name="Content Placeholder 4"/>
           <p:cNvPicPr>
             <a:picLocks noGrp="1"/>
           </p:cNvPicPr>
@@ -2440,7 +2441,7 @@
           </p:nvPr>
         </p:nvPicPr>
         <p:blipFill>
-          <a:blip cstate="print" r:embed="rId2"/>
+          <a:blip r:embed="rId2" cstate="print"/>
           <a:stretch>
             <a:fillRect/>
           </a:stretch>
@@ -2480,7 +2481,7 @@
           <a:chExt cx="0" cy="0"/>
         </a:xfrm>
       </p:grpSpPr>
-      <p:sp xmlns:a="http://schemas.openxmlformats.org/drawingml/2006/main" xmlns:r="http://schemas.openxmlformats.org/officeDocument/2006/relationships" xmlns:p="http://schemas.openxmlformats.org/presentationml/2006/main">
+      <p:sp>
         <p:nvSpPr>
           <p:cNvPr id="2" name="Title 1"/>
           <p:cNvSpPr>
@@ -2501,13 +2502,12 @@
           <a:lstStyle/>
           <a:p>
             <a:r>
-              <a:rPr/>
               <a:t>Comparison RDDam_HFDDam_MaleMRD_MaleMHFD_FemMRD_FemMHFD</a:t>
             </a:r>
           </a:p>
         </p:txBody>
       </p:sp>
-      <p:sp xmlns:a="http://schemas.openxmlformats.org/drawingml/2006/main" xmlns:r="http://schemas.openxmlformats.org/officeDocument/2006/relationships" xmlns:p="http://schemas.openxmlformats.org/presentationml/2006/main">
+      <p:sp>
         <p:nvSpPr>
           <p:cNvPr id="3" name="Text Placeholder 4"/>
           <p:cNvSpPr>
@@ -2528,13 +2528,12 @@
           <a:lstStyle/>
           <a:p>
             <a:r>
-              <a:rPr/>
               <a:t>Differential FDR&lt;0.25</a:t>
             </a:r>
           </a:p>
         </p:txBody>
       </p:sp>
-      <p:sp xmlns:a="http://schemas.openxmlformats.org/drawingml/2006/main" xmlns:r="http://schemas.openxmlformats.org/officeDocument/2006/relationships" xmlns:p="http://schemas.openxmlformats.org/presentationml/2006/main">
+      <p:sp>
         <p:nvSpPr>
           <p:cNvPr id="4" name="Text Placeholder 2"/>
           <p:cNvSpPr>
@@ -2555,15 +2554,14 @@
           <a:lstStyle/>
           <a:p>
             <a:r>
-              <a:rPr/>
               <a:t>Complete Set FDR=1</a:t>
             </a:r>
           </a:p>
         </p:txBody>
       </p:sp>
-      <p:pic xmlns:a="http://schemas.openxmlformats.org/drawingml/2006/main" xmlns:r="http://schemas.openxmlformats.org/officeDocument/2006/relationships" xmlns:p="http://schemas.openxmlformats.org/presentationml/2006/main">
+      <p:pic>
         <p:nvPicPr>
-          <p:cNvPr id="5" name="" descr=""/>
+          <p:cNvPr id="5" name="Content Placeholder 4"/>
           <p:cNvPicPr>
             <a:picLocks noGrp="1"/>
           </p:cNvPicPr>
@@ -2572,7 +2570,7 @@
           </p:nvPr>
         </p:nvPicPr>
         <p:blipFill>
-          <a:blip cstate="print" r:embed="rId2"/>
+          <a:blip r:embed="rId2" cstate="print"/>
           <a:stretch>
             <a:fillRect/>
           </a:stretch>
@@ -2587,9 +2585,9 @@
           </a:prstGeom>
         </p:spPr>
       </p:pic>
-      <p:pic xmlns:a="http://schemas.openxmlformats.org/drawingml/2006/main" xmlns:r="http://schemas.openxmlformats.org/officeDocument/2006/relationships" xmlns:p="http://schemas.openxmlformats.org/presentationml/2006/main">
+      <p:pic>
         <p:nvPicPr>
-          <p:cNvPr id="6" name="" descr=""/>
+          <p:cNvPr id="6" name="Content Placeholder 5"/>
           <p:cNvPicPr>
             <a:picLocks noGrp="1"/>
           </p:cNvPicPr>
@@ -2598,7 +2596,7 @@
           </p:nvPr>
         </p:nvPicPr>
         <p:blipFill>
-          <a:blip cstate="print" r:embed="rId3"/>
+          <a:blip r:embed="rId3" cstate="print"/>
           <a:stretch>
             <a:fillRect/>
           </a:stretch>
@@ -2638,7 +2636,7 @@
           <a:chExt cx="0" cy="0"/>
         </a:xfrm>
       </p:grpSpPr>
-      <p:sp xmlns:a="http://schemas.openxmlformats.org/drawingml/2006/main" xmlns:r="http://schemas.openxmlformats.org/officeDocument/2006/relationships" xmlns:p="http://schemas.openxmlformats.org/presentationml/2006/main">
+      <p:sp>
         <p:nvSpPr>
           <p:cNvPr id="2" name="Title 1"/>
           <p:cNvSpPr>
@@ -2659,13 +2657,12 @@
           <a:lstStyle/>
           <a:p>
             <a:r>
-              <a:rPr/>
               <a:t>Project Overview</a:t>
             </a:r>
           </a:p>
         </p:txBody>
       </p:sp>
-      <p:sp xmlns:a="http://schemas.openxmlformats.org/drawingml/2006/main" xmlns:r="http://schemas.openxmlformats.org/officeDocument/2006/relationships" xmlns:p="http://schemas.openxmlformats.org/presentationml/2006/main">
+      <p:sp>
         <p:nvSpPr>
           <p:cNvPr id="3" name="Content Placeholder 2"/>
           <p:cNvSpPr>
@@ -2682,91 +2679,104 @@
           </a:xfrm>
         </p:spPr>
         <p:txBody>
-          <a:bodyPr/>
+          <a:bodyPr>
+            <a:normAutofit fontScale="92500" lnSpcReduction="20000"/>
+          </a:bodyPr>
           <a:lstStyle/>
           <a:p>
-            <a:pPr/>
-            <a:r>
-              <a:rPr/>
+            <a:r>
+              <a:rPr dirty="0"/>
               <a:t>Samples</a:t>
             </a:r>
+            <a:r>
+              <a:rPr lang="en-US" dirty="0"/>
+              <a:t> </a:t>
+            </a:r>
+            <a:endParaRPr dirty="0"/>
           </a:p>
           <a:p>
             <a:pPr lvl="1"/>
             <a:r>
-              <a:rPr/>
+              <a:rPr dirty="0"/>
               <a:t>39 experimental samples</a:t>
             </a:r>
           </a:p>
           <a:p>
             <a:pPr lvl="1"/>
             <a:r>
-              <a:rPr/>
+              <a:rPr dirty="0"/>
               <a:t>3 liver control samples</a:t>
             </a:r>
           </a:p>
           <a:p>
-            <a:pPr/>
-            <a:r>
-              <a:rPr/>
+            <a:r>
+              <a:rPr dirty="0"/>
               <a:t>Total of 23 features from 1 methods</a:t>
             </a:r>
           </a:p>
           <a:p>
             <a:pPr lvl="1"/>
             <a:r>
-              <a:rPr/>
-              <a:t>AminoAcids was normalized by Internal Standard L-Tryptophan (ISTD) [CV = 0.05]</a:t>
-            </a:r>
-          </a:p>
-          <a:p>
-            <a:pPr/>
-            <a:r>
-              <a:rPr/>
+              <a:rPr dirty="0" err="1"/>
+              <a:t>AminoAcids</a:t>
+            </a:r>
+            <a:r>
+              <a:rPr dirty="0"/>
+              <a:t> was normalized by Internal Standard L-Tryptophan (ISTD) [CV = 0.05]</a:t>
+            </a:r>
+          </a:p>
+          <a:p>
+            <a:r>
+              <a:rPr dirty="0"/>
               <a:t>Comparisons performed</a:t>
             </a:r>
           </a:p>
           <a:p>
             <a:pPr lvl="1"/>
             <a:r>
-              <a:rPr/>
+              <a:rPr dirty="0"/>
               <a:t>t-test</a:t>
             </a:r>
           </a:p>
           <a:p>
             <a:pPr lvl="2"/>
             <a:r>
-              <a:rPr/>
+              <a:rPr dirty="0" err="1"/>
               <a:t>HFDDam_over_RDDam</a:t>
             </a:r>
+            <a:endParaRPr dirty="0"/>
           </a:p>
           <a:p>
             <a:pPr lvl="2"/>
             <a:r>
-              <a:rPr/>
+              <a:rPr dirty="0" err="1"/>
               <a:t>MaleMHFD_over_MaleMRD</a:t>
             </a:r>
+            <a:endParaRPr dirty="0"/>
           </a:p>
           <a:p>
             <a:pPr lvl="2"/>
             <a:r>
-              <a:rPr/>
+              <a:rPr dirty="0" err="1"/>
               <a:t>FemMHFD_over_FemMRD</a:t>
             </a:r>
+            <a:endParaRPr dirty="0"/>
           </a:p>
           <a:p>
             <a:pPr lvl="1"/>
             <a:r>
-              <a:rPr/>
+              <a:rPr dirty="0" err="1"/>
               <a:t>anova</a:t>
             </a:r>
+            <a:endParaRPr dirty="0"/>
           </a:p>
           <a:p>
             <a:pPr lvl="2"/>
             <a:r>
-              <a:rPr/>
+              <a:rPr dirty="0" err="1"/>
               <a:t>RDDam_HFDDam_MaleMRD_MaleMHFD_FemMRD_FemMHFD</a:t>
             </a:r>
+            <a:endParaRPr dirty="0"/>
           </a:p>
         </p:txBody>
       </p:sp>
@@ -2795,7 +2805,7 @@
           <a:chExt cx="0" cy="0"/>
         </a:xfrm>
       </p:grpSpPr>
-      <p:sp xmlns:a="http://schemas.openxmlformats.org/drawingml/2006/main" xmlns:r="http://schemas.openxmlformats.org/officeDocument/2006/relationships" xmlns:p="http://schemas.openxmlformats.org/presentationml/2006/main">
+      <p:sp>
         <p:nvSpPr>
           <p:cNvPr id="2" name="Title 1"/>
           <p:cNvSpPr>
@@ -2816,15 +2826,14 @@
           <a:lstStyle/>
           <a:p>
             <a:r>
-              <a:rPr/>
               <a:t>QA plots: all_samples</a:t>
             </a:r>
           </a:p>
         </p:txBody>
       </p:sp>
-      <p:pic xmlns:a="http://schemas.openxmlformats.org/drawingml/2006/main" xmlns:r="http://schemas.openxmlformats.org/officeDocument/2006/relationships" xmlns:p="http://schemas.openxmlformats.org/presentationml/2006/main">
+      <p:pic>
         <p:nvPicPr>
-          <p:cNvPr id="3" name="" descr=""/>
+          <p:cNvPr id="3" name="Content Placeholder 2"/>
           <p:cNvPicPr>
             <a:picLocks noGrp="1"/>
           </p:cNvPicPr>
@@ -2833,7 +2842,7 @@
           </p:nvPr>
         </p:nvPicPr>
         <p:blipFill>
-          <a:blip cstate="print" r:embed="rId2"/>
+          <a:blip r:embed="rId2" cstate="print"/>
           <a:stretch>
             <a:fillRect/>
           </a:stretch>
@@ -2873,7 +2882,7 @@
           <a:chExt cx="0" cy="0"/>
         </a:xfrm>
       </p:grpSpPr>
-      <p:sp xmlns:a="http://schemas.openxmlformats.org/drawingml/2006/main" xmlns:r="http://schemas.openxmlformats.org/officeDocument/2006/relationships" xmlns:p="http://schemas.openxmlformats.org/presentationml/2006/main">
+      <p:sp>
         <p:nvSpPr>
           <p:cNvPr id="2" name="Title 1"/>
           <p:cNvSpPr>
@@ -2894,15 +2903,14 @@
           <a:lstStyle/>
           <a:p>
             <a:r>
-              <a:rPr/>
               <a:t>QA plots: AminoAcids</a:t>
             </a:r>
           </a:p>
         </p:txBody>
       </p:sp>
-      <p:pic xmlns:a="http://schemas.openxmlformats.org/drawingml/2006/main" xmlns:r="http://schemas.openxmlformats.org/officeDocument/2006/relationships" xmlns:p="http://schemas.openxmlformats.org/presentationml/2006/main">
+      <p:pic>
         <p:nvPicPr>
-          <p:cNvPr id="3" name="" descr=""/>
+          <p:cNvPr id="3" name="Content Placeholder 2"/>
           <p:cNvPicPr>
             <a:picLocks noGrp="1"/>
           </p:cNvPicPr>
@@ -2911,7 +2919,7 @@
           </p:nvPr>
         </p:nvPicPr>
         <p:blipFill>
-          <a:blip cstate="print" r:embed="rId2"/>
+          <a:blip r:embed="rId2" cstate="print"/>
           <a:stretch>
             <a:fillRect/>
           </a:stretch>
@@ -2951,7 +2959,7 @@
           <a:chExt cx="0" cy="0"/>
         </a:xfrm>
       </p:grpSpPr>
-      <p:sp xmlns:a="http://schemas.openxmlformats.org/drawingml/2006/main" xmlns:r="http://schemas.openxmlformats.org/officeDocument/2006/relationships" xmlns:p="http://schemas.openxmlformats.org/presentationml/2006/main">
+      <p:sp>
         <p:nvSpPr>
           <p:cNvPr id="2" name="Title 1"/>
           <p:cNvSpPr>
@@ -2972,15 +2980,14 @@
           <a:lstStyle/>
           <a:p>
             <a:r>
-              <a:rPr/>
               <a:t>Liver Control: AminoAcids</a:t>
             </a:r>
           </a:p>
         </p:txBody>
       </p:sp>
-      <p:pic xmlns:a="http://schemas.openxmlformats.org/drawingml/2006/main" xmlns:r="http://schemas.openxmlformats.org/officeDocument/2006/relationships" xmlns:p="http://schemas.openxmlformats.org/presentationml/2006/main">
+      <p:pic>
         <p:nvPicPr>
-          <p:cNvPr id="3" name="" descr=""/>
+          <p:cNvPr id="3" name="Content Placeholder 2"/>
           <p:cNvPicPr>
             <a:picLocks noGrp="1"/>
           </p:cNvPicPr>
@@ -2989,7 +2996,7 @@
           </p:nvPr>
         </p:nvPicPr>
         <p:blipFill>
-          <a:blip cstate="print" r:embed="rId2"/>
+          <a:blip r:embed="rId2" cstate="print"/>
           <a:stretch>
             <a:fillRect/>
           </a:stretch>
@@ -3029,7 +3036,7 @@
           <a:chExt cx="0" cy="0"/>
         </a:xfrm>
       </p:grpSpPr>
-      <p:sp xmlns:a="http://schemas.openxmlformats.org/drawingml/2006/main" xmlns:r="http://schemas.openxmlformats.org/officeDocument/2006/relationships" xmlns:p="http://schemas.openxmlformats.org/presentationml/2006/main">
+      <p:sp>
         <p:nvSpPr>
           <p:cNvPr id="2" name="Title 1"/>
           <p:cNvSpPr>
@@ -3050,15 +3057,14 @@
           <a:lstStyle/>
           <a:p>
             <a:r>
-              <a:rPr/>
               <a:t>Internal Standards Distribution: AminoAcids</a:t>
             </a:r>
           </a:p>
         </p:txBody>
       </p:sp>
-      <p:pic xmlns:a="http://schemas.openxmlformats.org/drawingml/2006/main" xmlns:r="http://schemas.openxmlformats.org/officeDocument/2006/relationships" xmlns:p="http://schemas.openxmlformats.org/presentationml/2006/main">
+      <p:pic>
         <p:nvPicPr>
-          <p:cNvPr id="3" name="" descr=""/>
+          <p:cNvPr id="3" name="Content Placeholder 2"/>
           <p:cNvPicPr>
             <a:picLocks noGrp="1"/>
           </p:cNvPicPr>
@@ -3067,7 +3073,7 @@
           </p:nvPr>
         </p:nvPicPr>
         <p:blipFill>
-          <a:blip cstate="print" r:embed="rId2"/>
+          <a:blip r:embed="rId2" cstate="print"/>
           <a:stretch>
             <a:fillRect/>
           </a:stretch>
@@ -3107,7 +3113,7 @@
           <a:chExt cx="0" cy="0"/>
         </a:xfrm>
       </p:grpSpPr>
-      <p:sp xmlns:a="http://schemas.openxmlformats.org/drawingml/2006/main" xmlns:r="http://schemas.openxmlformats.org/officeDocument/2006/relationships" xmlns:p="http://schemas.openxmlformats.org/presentationml/2006/main">
+      <p:sp>
         <p:nvSpPr>
           <p:cNvPr id="2" name="Title 1"/>
           <p:cNvSpPr>
@@ -3128,13 +3134,12 @@
           <a:lstStyle/>
           <a:p>
             <a:r>
-              <a:rPr/>
               <a:t>Comparison HFDDam_over_RDDam</a:t>
             </a:r>
           </a:p>
         </p:txBody>
       </p:sp>
-      <p:sp xmlns:a="http://schemas.openxmlformats.org/drawingml/2006/main" xmlns:r="http://schemas.openxmlformats.org/officeDocument/2006/relationships" xmlns:p="http://schemas.openxmlformats.org/presentationml/2006/main">
+      <p:sp>
         <p:nvSpPr>
           <p:cNvPr id="3" name="Text Placeholder 4"/>
           <p:cNvSpPr>
@@ -3155,13 +3160,12 @@
           <a:lstStyle/>
           <a:p>
             <a:r>
-              <a:rPr/>
               <a:t>Normalized PCA</a:t>
             </a:r>
           </a:p>
         </p:txBody>
       </p:sp>
-      <p:sp xmlns:a="http://schemas.openxmlformats.org/drawingml/2006/main" xmlns:r="http://schemas.openxmlformats.org/officeDocument/2006/relationships" xmlns:p="http://schemas.openxmlformats.org/presentationml/2006/main">
+      <p:sp>
         <p:nvSpPr>
           <p:cNvPr id="4" name="Text Placeholder 2"/>
           <p:cNvSpPr>
@@ -3182,15 +3186,14 @@
           <a:lstStyle/>
           <a:p>
             <a:r>
-              <a:rPr/>
               <a:t>Raw PCA</a:t>
             </a:r>
           </a:p>
         </p:txBody>
       </p:sp>
-      <p:pic xmlns:a="http://schemas.openxmlformats.org/drawingml/2006/main" xmlns:r="http://schemas.openxmlformats.org/officeDocument/2006/relationships" xmlns:p="http://schemas.openxmlformats.org/presentationml/2006/main">
+      <p:pic>
         <p:nvPicPr>
-          <p:cNvPr id="5" name="" descr=""/>
+          <p:cNvPr id="5" name="Content Placeholder 4"/>
           <p:cNvPicPr>
             <a:picLocks noGrp="1"/>
           </p:cNvPicPr>
@@ -3199,7 +3202,7 @@
           </p:nvPr>
         </p:nvPicPr>
         <p:blipFill>
-          <a:blip cstate="print" r:embed="rId2"/>
+          <a:blip r:embed="rId2" cstate="print"/>
           <a:stretch>
             <a:fillRect/>
           </a:stretch>
@@ -3214,9 +3217,9 @@
           </a:prstGeom>
         </p:spPr>
       </p:pic>
-      <p:pic xmlns:a="http://schemas.openxmlformats.org/drawingml/2006/main" xmlns:r="http://schemas.openxmlformats.org/officeDocument/2006/relationships" xmlns:p="http://schemas.openxmlformats.org/presentationml/2006/main">
+      <p:pic>
         <p:nvPicPr>
-          <p:cNvPr id="6" name="" descr=""/>
+          <p:cNvPr id="6" name="Content Placeholder 5"/>
           <p:cNvPicPr>
             <a:picLocks noGrp="1"/>
           </p:cNvPicPr>
@@ -3225,7 +3228,7 @@
           </p:nvPr>
         </p:nvPicPr>
         <p:blipFill>
-          <a:blip cstate="print" r:embed="rId3"/>
+          <a:blip r:embed="rId3" cstate="print"/>
           <a:stretch>
             <a:fillRect/>
           </a:stretch>
@@ -3265,7 +3268,7 @@
           <a:chExt cx="0" cy="0"/>
         </a:xfrm>
       </p:grpSpPr>
-      <p:sp xmlns:a="http://schemas.openxmlformats.org/drawingml/2006/main" xmlns:r="http://schemas.openxmlformats.org/officeDocument/2006/relationships" xmlns:p="http://schemas.openxmlformats.org/presentationml/2006/main">
+      <p:sp>
         <p:nvSpPr>
           <p:cNvPr id="2" name="Title 1"/>
           <p:cNvSpPr>
@@ -3286,13 +3289,12 @@
           <a:lstStyle/>
           <a:p>
             <a:r>
-              <a:rPr/>
               <a:t>Comparison MaleMHFD_over_MaleMRD</a:t>
             </a:r>
           </a:p>
         </p:txBody>
       </p:sp>
-      <p:sp xmlns:a="http://schemas.openxmlformats.org/drawingml/2006/main" xmlns:r="http://schemas.openxmlformats.org/officeDocument/2006/relationships" xmlns:p="http://schemas.openxmlformats.org/presentationml/2006/main">
+      <p:sp>
         <p:nvSpPr>
           <p:cNvPr id="3" name="Text Placeholder 4"/>
           <p:cNvSpPr>
@@ -3313,13 +3315,12 @@
           <a:lstStyle/>
           <a:p>
             <a:r>
-              <a:rPr/>
               <a:t>Normalized PCA</a:t>
             </a:r>
           </a:p>
         </p:txBody>
       </p:sp>
-      <p:sp xmlns:a="http://schemas.openxmlformats.org/drawingml/2006/main" xmlns:r="http://schemas.openxmlformats.org/officeDocument/2006/relationships" xmlns:p="http://schemas.openxmlformats.org/presentationml/2006/main">
+      <p:sp>
         <p:nvSpPr>
           <p:cNvPr id="4" name="Text Placeholder 2"/>
           <p:cNvSpPr>
@@ -3340,15 +3341,14 @@
           <a:lstStyle/>
           <a:p>
             <a:r>
-              <a:rPr/>
               <a:t>Raw PCA</a:t>
             </a:r>
           </a:p>
         </p:txBody>
       </p:sp>
-      <p:pic xmlns:a="http://schemas.openxmlformats.org/drawingml/2006/main" xmlns:r="http://schemas.openxmlformats.org/officeDocument/2006/relationships" xmlns:p="http://schemas.openxmlformats.org/presentationml/2006/main">
+      <p:pic>
         <p:nvPicPr>
-          <p:cNvPr id="5" name="" descr=""/>
+          <p:cNvPr id="5" name="Content Placeholder 4"/>
           <p:cNvPicPr>
             <a:picLocks noGrp="1"/>
           </p:cNvPicPr>
@@ -3357,7 +3357,7 @@
           </p:nvPr>
         </p:nvPicPr>
         <p:blipFill>
-          <a:blip cstate="print" r:embed="rId2"/>
+          <a:blip r:embed="rId2" cstate="print"/>
           <a:stretch>
             <a:fillRect/>
           </a:stretch>
@@ -3372,9 +3372,9 @@
           </a:prstGeom>
         </p:spPr>
       </p:pic>
-      <p:pic xmlns:a="http://schemas.openxmlformats.org/drawingml/2006/main" xmlns:r="http://schemas.openxmlformats.org/officeDocument/2006/relationships" xmlns:p="http://schemas.openxmlformats.org/presentationml/2006/main">
+      <p:pic>
         <p:nvPicPr>
-          <p:cNvPr id="6" name="" descr=""/>
+          <p:cNvPr id="6" name="Content Placeholder 5"/>
           <p:cNvPicPr>
             <a:picLocks noGrp="1"/>
           </p:cNvPicPr>
@@ -3383,7 +3383,7 @@
           </p:nvPr>
         </p:nvPicPr>
         <p:blipFill>
-          <a:blip cstate="print" r:embed="rId3"/>
+          <a:blip r:embed="rId3" cstate="print"/>
           <a:stretch>
             <a:fillRect/>
           </a:stretch>
@@ -3423,7 +3423,7 @@
           <a:chExt cx="0" cy="0"/>
         </a:xfrm>
       </p:grpSpPr>
-      <p:sp xmlns:a="http://schemas.openxmlformats.org/drawingml/2006/main" xmlns:r="http://schemas.openxmlformats.org/officeDocument/2006/relationships" xmlns:p="http://schemas.openxmlformats.org/presentationml/2006/main">
+      <p:sp>
         <p:nvSpPr>
           <p:cNvPr id="2" name="Title 1"/>
           <p:cNvSpPr>
@@ -3444,13 +3444,12 @@
           <a:lstStyle/>
           <a:p>
             <a:r>
-              <a:rPr/>
               <a:t>Comparison FemMHFD_over_FemMRD</a:t>
             </a:r>
           </a:p>
         </p:txBody>
       </p:sp>
-      <p:sp xmlns:a="http://schemas.openxmlformats.org/drawingml/2006/main" xmlns:r="http://schemas.openxmlformats.org/officeDocument/2006/relationships" xmlns:p="http://schemas.openxmlformats.org/presentationml/2006/main">
+      <p:sp>
         <p:nvSpPr>
           <p:cNvPr id="3" name="Text Placeholder 4"/>
           <p:cNvSpPr>
@@ -3471,13 +3470,12 @@
           <a:lstStyle/>
           <a:p>
             <a:r>
-              <a:rPr/>
               <a:t>Normalized PCA</a:t>
             </a:r>
           </a:p>
         </p:txBody>
       </p:sp>
-      <p:sp xmlns:a="http://schemas.openxmlformats.org/drawingml/2006/main" xmlns:r="http://schemas.openxmlformats.org/officeDocument/2006/relationships" xmlns:p="http://schemas.openxmlformats.org/presentationml/2006/main">
+      <p:sp>
         <p:nvSpPr>
           <p:cNvPr id="4" name="Text Placeholder 2"/>
           <p:cNvSpPr>
@@ -3498,15 +3496,14 @@
           <a:lstStyle/>
           <a:p>
             <a:r>
-              <a:rPr/>
               <a:t>Raw PCA</a:t>
             </a:r>
           </a:p>
         </p:txBody>
       </p:sp>
-      <p:pic xmlns:a="http://schemas.openxmlformats.org/drawingml/2006/main" xmlns:r="http://schemas.openxmlformats.org/officeDocument/2006/relationships" xmlns:p="http://schemas.openxmlformats.org/presentationml/2006/main">
+      <p:pic>
         <p:nvPicPr>
-          <p:cNvPr id="5" name="" descr=""/>
+          <p:cNvPr id="5" name="Content Placeholder 4"/>
           <p:cNvPicPr>
             <a:picLocks noGrp="1"/>
           </p:cNvPicPr>
@@ -3515,7 +3512,7 @@
           </p:nvPr>
         </p:nvPicPr>
         <p:blipFill>
-          <a:blip cstate="print" r:embed="rId2"/>
+          <a:blip r:embed="rId2" cstate="print"/>
           <a:stretch>
             <a:fillRect/>
           </a:stretch>
@@ -3530,9 +3527,9 @@
           </a:prstGeom>
         </p:spPr>
       </p:pic>
-      <p:pic xmlns:a="http://schemas.openxmlformats.org/drawingml/2006/main" xmlns:r="http://schemas.openxmlformats.org/officeDocument/2006/relationships" xmlns:p="http://schemas.openxmlformats.org/presentationml/2006/main">
+      <p:pic>
         <p:nvPicPr>
-          <p:cNvPr id="6" name="" descr=""/>
+          <p:cNvPr id="6" name="Content Placeholder 5"/>
           <p:cNvPicPr>
             <a:picLocks noGrp="1"/>
           </p:cNvPicPr>
@@ -3541,7 +3538,7 @@
           </p:nvPr>
         </p:nvPicPr>
         <p:blipFill>
-          <a:blip cstate="print" r:embed="rId3"/>
+          <a:blip r:embed="rId3" cstate="print"/>
           <a:stretch>
             <a:fillRect/>
           </a:stretch>

</xml_diff>